<commit_message>
Updated extra rag pptx
</commit_message>
<xml_diff>
--- a/Extras/12 - RAG.pptx
+++ b/Extras/12 - RAG.pptx
@@ -2,46 +2,47 @@
 <file path=ppt/presentation.xml><?xml version="1.0" encoding="utf-8"?>
 <p:presentation xmlns:a="http://schemas.openxmlformats.org/drawingml/2006/main" xmlns:r="http://schemas.openxmlformats.org/officeDocument/2006/relationships" xmlns:p="http://schemas.openxmlformats.org/presentationml/2006/main" saveSubsetFonts="1" autoCompressPictures="0">
   <p:sldMasterIdLst>
-    <p:sldMasterId id="2147483648" r:id="rId4"/>
+    <p:sldMasterId id="2147483648" r:id="rId1"/>
   </p:sldMasterIdLst>
   <p:notesMasterIdLst>
-    <p:notesMasterId r:id="rId39"/>
+    <p:notesMasterId r:id="rId37"/>
   </p:notesMasterIdLst>
   <p:sldIdLst>
-    <p:sldId id="547" r:id="rId5"/>
-    <p:sldId id="548" r:id="rId6"/>
-    <p:sldId id="549" r:id="rId7"/>
-    <p:sldId id="550" r:id="rId8"/>
-    <p:sldId id="551" r:id="rId9"/>
-    <p:sldId id="552" r:id="rId10"/>
-    <p:sldId id="579" r:id="rId11"/>
-    <p:sldId id="553" r:id="rId12"/>
-    <p:sldId id="554" r:id="rId13"/>
-    <p:sldId id="555" r:id="rId14"/>
-    <p:sldId id="556" r:id="rId15"/>
-    <p:sldId id="557" r:id="rId16"/>
-    <p:sldId id="558" r:id="rId17"/>
-    <p:sldId id="559" r:id="rId18"/>
-    <p:sldId id="560" r:id="rId19"/>
-    <p:sldId id="561" r:id="rId20"/>
-    <p:sldId id="562" r:id="rId21"/>
-    <p:sldId id="563" r:id="rId22"/>
-    <p:sldId id="564" r:id="rId23"/>
-    <p:sldId id="565" r:id="rId24"/>
-    <p:sldId id="566" r:id="rId25"/>
-    <p:sldId id="567" r:id="rId26"/>
-    <p:sldId id="581" r:id="rId27"/>
-    <p:sldId id="568" r:id="rId28"/>
-    <p:sldId id="569" r:id="rId29"/>
-    <p:sldId id="570" r:id="rId30"/>
-    <p:sldId id="571" r:id="rId31"/>
-    <p:sldId id="572" r:id="rId32"/>
-    <p:sldId id="573" r:id="rId33"/>
-    <p:sldId id="574" r:id="rId34"/>
-    <p:sldId id="575" r:id="rId35"/>
-    <p:sldId id="576" r:id="rId36"/>
-    <p:sldId id="577" r:id="rId37"/>
-    <p:sldId id="578" r:id="rId38"/>
+    <p:sldId id="547" r:id="rId2"/>
+    <p:sldId id="548" r:id="rId3"/>
+    <p:sldId id="549" r:id="rId4"/>
+    <p:sldId id="550" r:id="rId5"/>
+    <p:sldId id="551" r:id="rId6"/>
+    <p:sldId id="552" r:id="rId7"/>
+    <p:sldId id="579" r:id="rId8"/>
+    <p:sldId id="553" r:id="rId9"/>
+    <p:sldId id="554" r:id="rId10"/>
+    <p:sldId id="555" r:id="rId11"/>
+    <p:sldId id="556" r:id="rId12"/>
+    <p:sldId id="557" r:id="rId13"/>
+    <p:sldId id="558" r:id="rId14"/>
+    <p:sldId id="559" r:id="rId15"/>
+    <p:sldId id="560" r:id="rId16"/>
+    <p:sldId id="561" r:id="rId17"/>
+    <p:sldId id="562" r:id="rId18"/>
+    <p:sldId id="563" r:id="rId19"/>
+    <p:sldId id="564" r:id="rId20"/>
+    <p:sldId id="565" r:id="rId21"/>
+    <p:sldId id="566" r:id="rId22"/>
+    <p:sldId id="567" r:id="rId23"/>
+    <p:sldId id="581" r:id="rId24"/>
+    <p:sldId id="568" r:id="rId25"/>
+    <p:sldId id="569" r:id="rId26"/>
+    <p:sldId id="570" r:id="rId27"/>
+    <p:sldId id="582" r:id="rId28"/>
+    <p:sldId id="571" r:id="rId29"/>
+    <p:sldId id="572" r:id="rId30"/>
+    <p:sldId id="573" r:id="rId31"/>
+    <p:sldId id="574" r:id="rId32"/>
+    <p:sldId id="575" r:id="rId33"/>
+    <p:sldId id="576" r:id="rId34"/>
+    <p:sldId id="577" r:id="rId35"/>
+    <p:sldId id="578" r:id="rId36"/>
   </p:sldIdLst>
   <p:sldSz cx="12192000" cy="6858000"/>
   <p:notesSz cx="6858000" cy="9144000"/>
@@ -242,7 +243,7 @@
           <a:p>
             <a:fld id="{3F00BCFC-AFFD-334C-A183-6116BAFDF92B}" type="datetimeFigureOut">
               <a:rPr lang="en-US" smtClean="0"/>
-              <a:t>9/8/2026</a:t>
+              <a:t>10/13/2026</a:t>
             </a:fld>
             <a:endParaRPr lang="en-US" dirty="0"/>
           </a:p>
@@ -20221,7 +20222,7 @@
                 <a:latin typeface="Consolas"/>
                 <a:cs typeface="Consolas"/>
               </a:rPr>
-              <a:t>Microsoft.SemanticKernel.Connectors.InMemory</a:t>
+              <a:t>CommunityToolkit.VectorData.InMemory</a:t>
             </a:r>
           </a:p>
           <a:p>
@@ -21707,8 +21708,25 @@
                 <a:latin typeface="Consolas"/>
                 <a:cs typeface="Consolas"/>
               </a:rPr>
-              <a:t>dotnet add package Microsoft.Extensions.VectorData.Abstractions</a:t>
-            </a:r>
+              <a:t>dotnet add package </a:t>
+            </a:r>
+            <a:r>
+              <a:rPr lang="en-US" sz="2000" b="0" dirty="0" err="1">
+                <a:solidFill>
+                  <a:srgbClr val="FFFFFF"/>
+                </a:solidFill>
+                <a:latin typeface="Consolas"/>
+                <a:cs typeface="Consolas"/>
+              </a:rPr>
+              <a:t>Microsoft.Extensions.VectorData.Abstractions</a:t>
+            </a:r>
+            <a:endParaRPr lang="en-US" sz="2000" b="0" dirty="0">
+              <a:solidFill>
+                <a:srgbClr val="FFFFFF"/>
+              </a:solidFill>
+              <a:latin typeface="Consolas"/>
+              <a:cs typeface="Consolas"/>
+            </a:endParaRPr>
           </a:p>
           <a:p>
             <a:pPr>
@@ -22051,7 +22069,27 @@
                 <a:latin typeface="Consolas"/>
                 <a:cs typeface="Consolas"/>
               </a:rPr>
-              <a:t>dotnet user-secrets set "OpenAI:Key" "sk-..."</a:t>
+              <a:t>dotnet user-secrets set "OpenAI:Key" "</a:t>
+            </a:r>
+            <a:r>
+              <a:rPr lang="en-US" sz="2000" b="0" dirty="0" err="1">
+                <a:solidFill>
+                  <a:srgbClr val="FFFFFF"/>
+                </a:solidFill>
+                <a:latin typeface="Consolas"/>
+                <a:cs typeface="Consolas"/>
+              </a:rPr>
+              <a:t>sk</a:t>
+            </a:r>
+            <a:r>
+              <a:rPr lang="en-US" sz="2000" b="0" dirty="0">
+                <a:solidFill>
+                  <a:srgbClr val="FFFFFF"/>
+                </a:solidFill>
+                <a:latin typeface="Consolas"/>
+                <a:cs typeface="Consolas"/>
+              </a:rPr>
+              <a:t>-..."</a:t>
             </a:r>
           </a:p>
         </p:txBody>
@@ -22393,13 +22431,52 @@
               <a:buNone/>
             </a:pPr>
             <a:r>
-              <a:rPr lang="en-US" sz="2000" b="0" dirty="0">
+              <a:rPr lang="en-US" b="0" dirty="0">
                 <a:solidFill>
                   <a:srgbClr val="FFFFFF"/>
                 </a:solidFill>
                 <a:latin typeface="Consolas"/>
                 <a:cs typeface="Consolas"/>
               </a:rPr>
+              <a:t>using </a:t>
+            </a:r>
+            <a:r>
+              <a:rPr lang="en-US" b="0" dirty="0" err="1">
+                <a:solidFill>
+                  <a:srgbClr val="FFFFFF"/>
+                </a:solidFill>
+                <a:latin typeface="Consolas"/>
+                <a:cs typeface="Consolas"/>
+              </a:rPr>
+              <a:t>System.Text</a:t>
+            </a:r>
+            <a:r>
+              <a:rPr lang="en-US" b="0" dirty="0">
+                <a:solidFill>
+                  <a:srgbClr val="FFFFFF"/>
+                </a:solidFill>
+                <a:latin typeface="Consolas"/>
+                <a:cs typeface="Consolas"/>
+              </a:rPr>
+              <a:t>;</a:t>
+            </a:r>
+            <a:br>
+              <a:rPr lang="en-US" b="0" dirty="0">
+                <a:solidFill>
+                  <a:srgbClr val="FFFFFF"/>
+                </a:solidFill>
+                <a:latin typeface="Consolas"/>
+                <a:cs typeface="Consolas"/>
+              </a:rPr>
+            </a:br>
+            <a:r>
+              <a:rPr lang="en-US" b="0" dirty="0">
+                <a:solidFill>
+                  <a:srgbClr val="FFFFFF"/>
+                </a:solidFill>
+                <a:latin typeface="Consolas"/>
+                <a:cs typeface="Consolas"/>
+              </a:rPr>
               <a:t>using OpenAI;</a:t>
             </a:r>
           </a:p>
@@ -22411,7 +22488,7 @@
               <a:buNone/>
             </a:pPr>
             <a:r>
-              <a:rPr lang="en-US" sz="2000" dirty="0">
+              <a:rPr lang="en-US" dirty="0">
                 <a:solidFill>
                   <a:srgbClr val="FFFFFF"/>
                 </a:solidFill>
@@ -22420,7 +22497,7 @@
               <a:t>using </a:t>
             </a:r>
             <a:r>
-              <a:rPr lang="en-US" sz="2000" dirty="0" err="1">
+              <a:rPr lang="en-US" dirty="0" err="1">
                 <a:solidFill>
                   <a:srgbClr val="FFFFFF"/>
                 </a:solidFill>
@@ -22429,7 +22506,7 @@
               <a:t>Microsoft.Extensions.Configuration</a:t>
             </a:r>
             <a:r>
-              <a:rPr lang="en-US" sz="2000" dirty="0">
+              <a:rPr lang="en-US" dirty="0">
                 <a:solidFill>
                   <a:srgbClr val="FFFFFF"/>
                 </a:solidFill>
@@ -22446,7 +22523,7 @@
               <a:buNone/>
             </a:pPr>
             <a:r>
-              <a:rPr lang="en-US" sz="2000" dirty="0">
+              <a:rPr lang="en-US" dirty="0">
                 <a:solidFill>
                   <a:srgbClr val="FFFFFF"/>
                 </a:solidFill>
@@ -22463,7 +22540,7 @@
               <a:buNone/>
             </a:pPr>
             <a:r>
-              <a:rPr lang="en-US" sz="2000" dirty="0">
+              <a:rPr lang="en-US" dirty="0">
                 <a:solidFill>
                   <a:srgbClr val="FFFFFF"/>
                 </a:solidFill>
@@ -22472,7 +22549,7 @@
               <a:t>using </a:t>
             </a:r>
             <a:r>
-              <a:rPr lang="en-US" sz="2000" dirty="0" err="1">
+              <a:rPr lang="en-US" dirty="0" err="1">
                 <a:solidFill>
                   <a:srgbClr val="FFFFFF"/>
                 </a:solidFill>
@@ -22481,7 +22558,7 @@
               <a:t>Microsoft.Extensions.VectorData</a:t>
             </a:r>
             <a:r>
-              <a:rPr lang="en-US" sz="2000" dirty="0">
+              <a:rPr lang="en-US" dirty="0">
                 <a:solidFill>
                   <a:srgbClr val="FFFFFF"/>
                 </a:solidFill>
@@ -22492,7 +22569,7 @@
           </a:p>
           <a:p>
             <a:r>
-              <a:rPr lang="en-US" sz="2000" dirty="0">
+              <a:rPr lang="en-US" dirty="0">
                 <a:solidFill>
                   <a:srgbClr val="FFFFFF"/>
                 </a:solidFill>
@@ -22501,7 +22578,7 @@
               <a:t>using </a:t>
             </a:r>
             <a:r>
-              <a:rPr lang="en-US" sz="2000" dirty="0" err="1">
+              <a:rPr lang="en-US" dirty="0" err="1">
                 <a:solidFill>
                   <a:srgbClr val="FFFFFF"/>
                 </a:solidFill>
@@ -22510,7 +22587,7 @@
               <a:t>CommunityToolkit.VectorData.InMemory</a:t>
             </a:r>
             <a:r>
-              <a:rPr lang="en-US" sz="2000" dirty="0">
+              <a:rPr lang="en-US" dirty="0">
                 <a:solidFill>
                   <a:srgbClr val="FFFFFF"/>
                 </a:solidFill>
@@ -22526,7 +22603,7 @@
               </a:lnSpc>
               <a:buNone/>
             </a:pPr>
-            <a:endParaRPr lang="en-US" sz="2000" b="0" dirty="0">
+            <a:endParaRPr lang="en-US" b="0" dirty="0">
               <a:solidFill>
                 <a:srgbClr val="FFFFFF"/>
               </a:solidFill>
@@ -22542,7 +22619,7 @@
               <a:buNone/>
             </a:pPr>
             <a:r>
-              <a:rPr lang="en-US" sz="2000" b="0" dirty="0">
+              <a:rPr lang="en-US" b="0" dirty="0">
                 <a:solidFill>
                   <a:srgbClr val="FFFFFF"/>
                 </a:solidFill>
@@ -22552,7 +22629,7 @@
               <a:t>var config = new </a:t>
             </a:r>
             <a:r>
-              <a:rPr lang="en-US" sz="2000" b="0" dirty="0" err="1">
+              <a:rPr lang="en-US" b="0" dirty="0" err="1">
                 <a:solidFill>
                   <a:srgbClr val="FFFFFF"/>
                 </a:solidFill>
@@ -22562,7 +22639,7 @@
               <a:t>ConfigurationBuilder</a:t>
             </a:r>
             <a:r>
-              <a:rPr lang="en-US" sz="2000" b="0" dirty="0">
+              <a:rPr lang="en-US" b="0" dirty="0">
                 <a:solidFill>
                   <a:srgbClr val="FFFFFF"/>
                 </a:solidFill>
@@ -22580,7 +22657,7 @@
               <a:buNone/>
             </a:pPr>
             <a:r>
-              <a:rPr lang="en-US" sz="2000" b="0" dirty="0">
+              <a:rPr lang="en-US" b="0" dirty="0">
                 <a:solidFill>
                   <a:srgbClr val="FFFFFF"/>
                 </a:solidFill>
@@ -22590,7 +22667,7 @@
               <a:t>    .</a:t>
             </a:r>
             <a:r>
-              <a:rPr lang="en-US" sz="2000" b="0" dirty="0" err="1">
+              <a:rPr lang="en-US" b="0" dirty="0" err="1">
                 <a:solidFill>
                   <a:srgbClr val="FFFFFF"/>
                 </a:solidFill>
@@ -22600,7 +22677,7 @@
               <a:t>AddUserSecrets</a:t>
             </a:r>
             <a:r>
-              <a:rPr lang="en-US" sz="2000" b="0" dirty="0">
+              <a:rPr lang="en-US" b="0" dirty="0">
                 <a:solidFill>
                   <a:srgbClr val="FFFFFF"/>
                 </a:solidFill>
@@ -22618,7 +22695,7 @@
               <a:buNone/>
             </a:pPr>
             <a:r>
-              <a:rPr lang="en-US" sz="2000" b="0" dirty="0">
+              <a:rPr lang="en-US" b="0" dirty="0">
                 <a:solidFill>
                   <a:srgbClr val="FFFFFF"/>
                 </a:solidFill>
@@ -24481,7 +24558,7 @@
       </p:grpSpPr>
       <p:sp>
         <p:nvSpPr>
-          <p:cNvPr id="246" name="SlideNum 246"/>
+          <p:cNvPr id="2" name="SlideNum 2"/>
           <p:cNvSpPr txBox="1"/>
           <p:nvPr/>
         </p:nvSpPr>
@@ -24603,7 +24680,7 @@
                 <a:latin typeface="Tw Cen MT"/>
                 <a:cs typeface="Tw Cen MT"/>
               </a:rPr>
-              <a:t>INGEST: EMBED AND UPSERT</a:t>
+              <a:t>INGEST: CHUNK THE TEXT</a:t>
             </a:r>
           </a:p>
         </p:txBody>
@@ -24617,7 +24694,7 @@
         <p:spPr>
           <a:xfrm>
             <a:off x="640080" y="1691640"/>
-            <a:ext cx="10881360" cy="3513328"/>
+            <a:ext cx="10881360" cy="4206240"/>
           </a:xfrm>
           <a:prstGeom prst="roundRect">
             <a:avLst>
@@ -24647,8 +24724,8 @@
         </p:nvSpPr>
         <p:spPr>
           <a:xfrm>
-            <a:off x="960120" y="1975104"/>
-            <a:ext cx="10332720" cy="2946400"/>
+            <a:off x="960120" y="1920240"/>
+            <a:ext cx="10332720" cy="3886200"/>
           </a:xfrm>
           <a:prstGeom prst="rect">
             <a:avLst/>
@@ -24663,160 +24740,254 @@
           <a:p>
             <a:pPr algn="l">
               <a:lnSpc>
-                <a:spcPct val="118000"/>
+                <a:spcPct val="100000"/>
               </a:lnSpc>
               <a:buNone/>
             </a:pPr>
             <a:r>
-              <a:rPr lang="en-US" sz="2000" b="0" dirty="0">
-                <a:solidFill>
-                  <a:srgbClr val="92D050"/>
+              <a:rPr lang="en-US" sz="1800" b="0" dirty="0">
+                <a:solidFill>
+                  <a:srgbClr val="FFFFFF"/>
                 </a:solidFill>
                 <a:latin typeface="Consolas"/>
                 <a:cs typeface="Consolas"/>
               </a:rPr>
-              <a:t>// continue inside for loop:</a:t>
+              <a:t>static IEnumerable&lt;string&gt; Chunk(string text, int max = 1500)</a:t>
             </a:r>
           </a:p>
           <a:p>
             <a:pPr algn="l">
               <a:lnSpc>
-                <a:spcPct val="118000"/>
+                <a:spcPct val="100000"/>
               </a:lnSpc>
               <a:buNone/>
             </a:pPr>
-            <a:endParaRPr lang="en-US" sz="2000" b="0" dirty="0">
-              <a:solidFill>
-                <a:srgbClr val="FFFFFF"/>
-              </a:solidFill>
-              <a:latin typeface="Consolas"/>
-              <a:cs typeface="Consolas"/>
-            </a:endParaRPr>
-          </a:p>
-          <a:p>
-            <a:pPr algn="l">
-              <a:lnSpc>
-                <a:spcPct val="118000"/>
-              </a:lnSpc>
-              <a:buNone/>
-            </a:pPr>
-            <a:r>
-              <a:rPr lang="en-US" sz="2000" b="0" dirty="0">
+            <a:r>
+              <a:rPr lang="en-US" sz="1800" b="0" dirty="0">
                 <a:solidFill>
                   <a:srgbClr val="FFFFFF"/>
                 </a:solidFill>
                 <a:latin typeface="Consolas"/>
                 <a:cs typeface="Consolas"/>
               </a:rPr>
-              <a:t>var v = await </a:t>
-            </a:r>
-            <a:r>
-              <a:rPr lang="en-US" sz="2000" b="0" dirty="0" err="1">
+              <a:t>{</a:t>
+            </a:r>
+          </a:p>
+          <a:p>
+            <a:pPr algn="l">
+              <a:lnSpc>
+                <a:spcPct val="100000"/>
+              </a:lnSpc>
+              <a:buNone/>
+            </a:pPr>
+            <a:r>
+              <a:rPr lang="en-US" sz="1800" b="0" dirty="0">
                 <a:solidFill>
                   <a:srgbClr val="FFFFFF"/>
                 </a:solidFill>
                 <a:latin typeface="Consolas"/>
                 <a:cs typeface="Consolas"/>
               </a:rPr>
-              <a:t>embedder.GenerateAsync</a:t>
-            </a:r>
-            <a:r>
-              <a:rPr lang="en-US" sz="2000" b="0" dirty="0">
+              <a:t>    text = text.Replace("\r\n", "\n");</a:t>
+            </a:r>
+          </a:p>
+          <a:p>
+            <a:pPr algn="l">
+              <a:lnSpc>
+                <a:spcPct val="100000"/>
+              </a:lnSpc>
+              <a:buNone/>
+            </a:pPr>
+            <a:r>
+              <a:rPr lang="en-US" sz="1800" b="0" dirty="0">
                 <a:solidFill>
                   <a:srgbClr val="FFFFFF"/>
                 </a:solidFill>
                 <a:latin typeface="Consolas"/>
                 <a:cs typeface="Consolas"/>
               </a:rPr>
-              <a:t>(text);</a:t>
+              <a:t>    var sb = new StringBuilder();</a:t>
             </a:r>
           </a:p>
           <a:p>
             <a:pPr algn="l">
               <a:lnSpc>
-                <a:spcPct val="118000"/>
+                <a:spcPct val="100000"/>
               </a:lnSpc>
               <a:buNone/>
             </a:pPr>
             <a:r>
-              <a:rPr lang="en-US" sz="2000" b="0" dirty="0">
+              <a:rPr lang="en-US" sz="1800" b="0" dirty="0">
                 <a:solidFill>
                   <a:srgbClr val="FFFFFF"/>
                 </a:solidFill>
                 <a:latin typeface="Consolas"/>
                 <a:cs typeface="Consolas"/>
               </a:rPr>
-              <a:t>    await pages.UpsertAsync(new PageChunk {</a:t>
+              <a:t>    var paras = text.Split("\n\n",</a:t>
             </a:r>
           </a:p>
           <a:p>
             <a:pPr algn="l">
               <a:lnSpc>
-                <a:spcPct val="118000"/>
+                <a:spcPct val="100000"/>
               </a:lnSpc>
               <a:buNone/>
             </a:pPr>
             <a:r>
-              <a:rPr lang="en-US" sz="2000" b="0" dirty="0">
+              <a:rPr lang="en-US" sz="1800" b="0" dirty="0">
                 <a:solidFill>
                   <a:srgbClr val="FFFFFF"/>
                 </a:solidFill>
                 <a:latin typeface="Consolas"/>
                 <a:cs typeface="Consolas"/>
               </a:rPr>
-              <a:t>        Id = Guid.NewGuid().ToString(),</a:t>
+              <a:t>                    StringSplitOptions.RemoveEmptyEntries);</a:t>
             </a:r>
           </a:p>
           <a:p>
             <a:pPr algn="l">
               <a:lnSpc>
-                <a:spcPct val="118000"/>
+                <a:spcPct val="100000"/>
               </a:lnSpc>
               <a:buNone/>
             </a:pPr>
             <a:r>
-              <a:rPr lang="en-US" sz="2000" b="0" dirty="0">
+              <a:rPr lang="en-US" sz="1800" b="0" dirty="0">
                 <a:solidFill>
                   <a:srgbClr val="FFFFFF"/>
                 </a:solidFill>
                 <a:latin typeface="Consolas"/>
                 <a:cs typeface="Consolas"/>
               </a:rPr>
-              <a:t>        Text = text, Url = file,</a:t>
+              <a:t>    foreach (var p in paras)</a:t>
             </a:r>
           </a:p>
           <a:p>
             <a:pPr algn="l">
               <a:lnSpc>
-                <a:spcPct val="118000"/>
+                <a:spcPct val="100000"/>
               </a:lnSpc>
               <a:buNone/>
             </a:pPr>
             <a:r>
-              <a:rPr lang="en-US" sz="2000" b="0" dirty="0">
+              <a:rPr lang="en-US" sz="1800" b="0" dirty="0">
                 <a:solidFill>
                   <a:srgbClr val="FFFFFF"/>
                 </a:solidFill>
                 <a:latin typeface="Consolas"/>
                 <a:cs typeface="Consolas"/>
               </a:rPr>
-              <a:t>        Embedding = v.Vector });</a:t>
+              <a:t>    {</a:t>
             </a:r>
           </a:p>
           <a:p>
             <a:pPr algn="l">
               <a:lnSpc>
-                <a:spcPct val="118000"/>
+                <a:spcPct val="100000"/>
               </a:lnSpc>
               <a:buNone/>
             </a:pPr>
-            <a:endParaRPr lang="en-US" sz="2000" b="0" dirty="0">
-              <a:solidFill>
-                <a:srgbClr val="FFFFFF"/>
-              </a:solidFill>
-              <a:latin typeface="Consolas"/>
-              <a:cs typeface="Consolas"/>
-            </a:endParaRPr>
+            <a:r>
+              <a:rPr lang="en-US" sz="1800" b="0" dirty="0">
+                <a:solidFill>
+                  <a:srgbClr val="FFFFFF"/>
+                </a:solidFill>
+                <a:latin typeface="Consolas"/>
+                <a:cs typeface="Consolas"/>
+              </a:rPr>
+              <a:t>        if (sb.Length + p.Length &gt; max &amp;&amp; sb.Length &gt; 0)</a:t>
+            </a:r>
+          </a:p>
+          <a:p>
+            <a:pPr algn="l">
+              <a:lnSpc>
+                <a:spcPct val="100000"/>
+              </a:lnSpc>
+              <a:buNone/>
+            </a:pPr>
+            <a:r>
+              <a:rPr lang="en-US" sz="1800" b="0" dirty="0">
+                <a:solidFill>
+                  <a:srgbClr val="FFFFFF"/>
+                </a:solidFill>
+                <a:latin typeface="Consolas"/>
+                <a:cs typeface="Consolas"/>
+              </a:rPr>
+              <a:t>        { yield return sb.ToString(); sb.Clear(); }</a:t>
+            </a:r>
+          </a:p>
+          <a:p>
+            <a:pPr algn="l">
+              <a:lnSpc>
+                <a:spcPct val="100000"/>
+              </a:lnSpc>
+              <a:buNone/>
+            </a:pPr>
+            <a:r>
+              <a:rPr lang="en-US" sz="1800" b="0" dirty="0">
+                <a:solidFill>
+                  <a:srgbClr val="FFFFFF"/>
+                </a:solidFill>
+                <a:latin typeface="Consolas"/>
+                <a:cs typeface="Consolas"/>
+              </a:rPr>
+              <a:t>        sb.AppendLine(p.Trim());</a:t>
+            </a:r>
+          </a:p>
+          <a:p>
+            <a:pPr algn="l">
+              <a:lnSpc>
+                <a:spcPct val="100000"/>
+              </a:lnSpc>
+              <a:buNone/>
+            </a:pPr>
+            <a:r>
+              <a:rPr lang="en-US" sz="1800" b="0" dirty="0">
+                <a:solidFill>
+                  <a:srgbClr val="FFFFFF"/>
+                </a:solidFill>
+                <a:latin typeface="Consolas"/>
+                <a:cs typeface="Consolas"/>
+              </a:rPr>
+              <a:t>    }</a:t>
+            </a:r>
+          </a:p>
+          <a:p>
+            <a:pPr algn="l">
+              <a:lnSpc>
+                <a:spcPct val="100000"/>
+              </a:lnSpc>
+              <a:buNone/>
+            </a:pPr>
+            <a:r>
+              <a:rPr lang="en-US" sz="1800" b="0" dirty="0">
+                <a:solidFill>
+                  <a:srgbClr val="FFFFFF"/>
+                </a:solidFill>
+                <a:latin typeface="Consolas"/>
+                <a:cs typeface="Consolas"/>
+              </a:rPr>
+              <a:t>    if (sb.Length &gt; 0) yield return sb.ToString();</a:t>
+            </a:r>
+          </a:p>
+          <a:p>
+            <a:pPr algn="l">
+              <a:lnSpc>
+                <a:spcPct val="100000"/>
+              </a:lnSpc>
+              <a:buNone/>
+            </a:pPr>
+            <a:r>
+              <a:rPr lang="en-US" sz="1800" b="0" dirty="0">
+                <a:solidFill>
+                  <a:srgbClr val="FFFFFF"/>
+                </a:solidFill>
+                <a:latin typeface="Consolas"/>
+                <a:cs typeface="Consolas"/>
+              </a:rPr>
+              <a:t>}</a:t>
+            </a:r>
           </a:p>
         </p:txBody>
       </p:sp>
@@ -24828,7 +24999,7 @@
         </p:nvSpPr>
         <p:spPr>
           <a:xfrm>
-            <a:off x="640080" y="5406136"/>
+            <a:off x="640080" y="5980176"/>
             <a:ext cx="10881360" cy="457200"/>
           </a:xfrm>
           <a:prstGeom prst="rect">
@@ -24856,7 +25027,7 @@
                 <a:latin typeface="Segoe UI Light"/>
                 <a:cs typeface="Segoe UI Light"/>
               </a:rPr>
-              <a:t>✓  The texts and their vectors are stored together</a:t>
+              <a:t>✓  Packs whole paragraphs into chunks of up to max characters</a:t>
             </a:r>
           </a:p>
         </p:txBody>
@@ -24929,7 +25100,7 @@
       </p:grpSpPr>
       <p:sp>
         <p:nvSpPr>
-          <p:cNvPr id="253" name="SlideNum 253"/>
+          <p:cNvPr id="246" name="SlideNum 246"/>
           <p:cNvSpPr txBox="1"/>
           <p:nvPr/>
         </p:nvSpPr>
@@ -24973,7 +25144,7 @@
       </p:sp>
       <p:sp>
         <p:nvSpPr>
-          <p:cNvPr id="254" name="Pill 254"/>
+          <p:cNvPr id="247" name="Pill 247"/>
           <p:cNvSpPr/>
           <p:nvPr/>
         </p:nvSpPr>
@@ -25017,7 +25188,7 @@
       </p:sp>
       <p:sp>
         <p:nvSpPr>
-          <p:cNvPr id="255" name="TextBox 255"/>
+          <p:cNvPr id="248" name="TextBox 248"/>
           <p:cNvSpPr txBox="1"/>
           <p:nvPr/>
         </p:nvSpPr>
@@ -25051,21 +25222,21 @@
                 <a:latin typeface="Tw Cen MT"/>
                 <a:cs typeface="Tw Cen MT"/>
               </a:rPr>
-              <a:t>QUERY: SEARCH THE STORE</a:t>
-            </a:r>
-          </a:p>
-        </p:txBody>
-      </p:sp>
-      <p:sp>
-        <p:nvSpPr>
-          <p:cNvPr id="256" name="Card 256"/>
+              <a:t>INGEST: EMBED AND UPSERT</a:t>
+            </a:r>
+          </a:p>
+        </p:txBody>
+      </p:sp>
+      <p:sp>
+        <p:nvSpPr>
+          <p:cNvPr id="249" name="Card 249"/>
           <p:cNvSpPr/>
           <p:nvPr/>
         </p:nvSpPr>
         <p:spPr>
           <a:xfrm>
             <a:off x="640080" y="1691640"/>
-            <a:ext cx="10881360" cy="2776728"/>
+            <a:ext cx="10881360" cy="3513328"/>
           </a:xfrm>
           <a:prstGeom prst="roundRect">
             <a:avLst>
@@ -25089,14 +25260,14 @@
       </p:sp>
       <p:sp>
         <p:nvSpPr>
-          <p:cNvPr id="257" name="TextBox 257"/>
+          <p:cNvPr id="250" name="TextBox 250"/>
           <p:cNvSpPr txBox="1"/>
           <p:nvPr/>
         </p:nvSpPr>
         <p:spPr>
           <a:xfrm>
             <a:off x="960120" y="1975104"/>
-            <a:ext cx="10332720" cy="2209800"/>
+            <a:ext cx="10332720" cy="2946400"/>
           </a:xfrm>
           <a:prstGeom prst="rect">
             <a:avLst/>
@@ -25111,25 +25282,25 @@
           <a:p>
             <a:pPr algn="l">
               <a:lnSpc>
-                <a:spcPct val="118000"/>
+                <a:spcPct val="110000"/>
               </a:lnSpc>
               <a:buNone/>
             </a:pPr>
             <a:r>
               <a:rPr lang="en-US" sz="2000" b="0" dirty="0">
                 <a:solidFill>
-                  <a:srgbClr val="FFFFFF"/>
+                  <a:srgbClr val="92D050"/>
                 </a:solidFill>
                 <a:latin typeface="Consolas"/>
                 <a:cs typeface="Consolas"/>
               </a:rPr>
-              <a:t>Console.Write("Question: ");</a:t>
+              <a:t>// continue inside for loop:</a:t>
             </a:r>
           </a:p>
           <a:p>
             <a:pPr algn="l">
               <a:lnSpc>
-                <a:spcPct val="118000"/>
+                <a:spcPct val="110000"/>
               </a:lnSpc>
               <a:buNone/>
             </a:pPr>
@@ -25141,22 +25312,13 @@
                 <a:latin typeface="Consolas"/>
                 <a:cs typeface="Consolas"/>
               </a:rPr>
-              <a:t>var question = Console.ReadLine()!;</a:t>
+              <a:t>foreach (var chunk in Chunk(text, 1000))</a:t>
             </a:r>
           </a:p>
           <a:p>
             <a:pPr algn="l">
               <a:lnSpc>
-                <a:spcPct val="118000"/>
-              </a:lnSpc>
-              <a:buNone/>
-            </a:pPr>
-            <a:endParaRPr lang="en-US" sz="2000" dirty="0"/>
-          </a:p>
-          <a:p>
-            <a:pPr algn="l">
-              <a:lnSpc>
-                <a:spcPct val="118000"/>
+                <a:spcPct val="110000"/>
               </a:lnSpc>
               <a:buNone/>
             </a:pPr>
@@ -25168,22 +25330,13 @@
                 <a:latin typeface="Consolas"/>
                 <a:cs typeface="Consolas"/>
               </a:rPr>
-              <a:t>var qv = await embedder.GenerateAsync(question);</a:t>
+              <a:t>{</a:t>
             </a:r>
           </a:p>
           <a:p>
             <a:pPr algn="l">
               <a:lnSpc>
-                <a:spcPct val="118000"/>
-              </a:lnSpc>
-              <a:buNone/>
-            </a:pPr>
-            <a:endParaRPr lang="en-US" sz="2000" dirty="0"/>
-          </a:p>
-          <a:p>
-            <a:pPr algn="l">
-              <a:lnSpc>
-                <a:spcPct val="118000"/>
+                <a:spcPct val="110000"/>
               </a:lnSpc>
               <a:buNone/>
             </a:pPr>
@@ -25195,20 +25348,110 @@
                 <a:latin typeface="Consolas"/>
                 <a:cs typeface="Consolas"/>
               </a:rPr>
-              <a:t>var hits = pages.SearchAsync(qv.Vector, top: 3);</a:t>
-            </a:r>
-          </a:p>
-        </p:txBody>
-      </p:sp>
-      <p:sp>
-        <p:nvSpPr>
-          <p:cNvPr id="258" name="TextBox 258"/>
+              <a:t>    var v = await embedder.GenerateAsync(chunk);</a:t>
+            </a:r>
+          </a:p>
+          <a:p>
+            <a:pPr algn="l">
+              <a:lnSpc>
+                <a:spcPct val="110000"/>
+              </a:lnSpc>
+              <a:buNone/>
+            </a:pPr>
+            <a:r>
+              <a:rPr lang="en-US" sz="2000" b="0" dirty="0">
+                <a:solidFill>
+                  <a:srgbClr val="FFFFFF"/>
+                </a:solidFill>
+                <a:latin typeface="Consolas"/>
+                <a:cs typeface="Consolas"/>
+              </a:rPr>
+              <a:t>    await pages.UpsertAsync(new PageChunk {</a:t>
+            </a:r>
+          </a:p>
+          <a:p>
+            <a:pPr algn="l">
+              <a:lnSpc>
+                <a:spcPct val="110000"/>
+              </a:lnSpc>
+              <a:buNone/>
+            </a:pPr>
+            <a:r>
+              <a:rPr lang="en-US" sz="2000" b="0" dirty="0">
+                <a:solidFill>
+                  <a:srgbClr val="FFFFFF"/>
+                </a:solidFill>
+                <a:latin typeface="Consolas"/>
+                <a:cs typeface="Consolas"/>
+              </a:rPr>
+              <a:t>        Id = Guid.NewGuid().ToString(),</a:t>
+            </a:r>
+          </a:p>
+          <a:p>
+            <a:pPr algn="l">
+              <a:lnSpc>
+                <a:spcPct val="110000"/>
+              </a:lnSpc>
+              <a:buNone/>
+            </a:pPr>
+            <a:r>
+              <a:rPr lang="en-US" sz="2000" b="0" dirty="0">
+                <a:solidFill>
+                  <a:srgbClr val="FFFFFF"/>
+                </a:solidFill>
+                <a:latin typeface="Consolas"/>
+                <a:cs typeface="Consolas"/>
+              </a:rPr>
+              <a:t>        Text = chunk, Url = file,</a:t>
+            </a:r>
+          </a:p>
+          <a:p>
+            <a:pPr algn="l">
+              <a:lnSpc>
+                <a:spcPct val="110000"/>
+              </a:lnSpc>
+              <a:buNone/>
+            </a:pPr>
+            <a:r>
+              <a:rPr lang="en-US" sz="2000" b="0" dirty="0">
+                <a:solidFill>
+                  <a:srgbClr val="FFFFFF"/>
+                </a:solidFill>
+                <a:latin typeface="Consolas"/>
+                <a:cs typeface="Consolas"/>
+              </a:rPr>
+              <a:t>        Embedding = v.Vector });</a:t>
+            </a:r>
+          </a:p>
+          <a:p>
+            <a:pPr algn="l">
+              <a:lnSpc>
+                <a:spcPct val="110000"/>
+              </a:lnSpc>
+              <a:buNone/>
+            </a:pPr>
+            <a:r>
+              <a:rPr lang="en-US" sz="2000" b="0" dirty="0">
+                <a:solidFill>
+                  <a:srgbClr val="FFFFFF"/>
+                </a:solidFill>
+                <a:latin typeface="Consolas"/>
+                <a:cs typeface="Consolas"/>
+              </a:rPr>
+              <a:t>}</a:t>
+            </a:r>
+          </a:p>
+        </p:txBody>
+      </p:sp>
+      <p:sp>
+        <p:nvSpPr>
+          <p:cNvPr id="251" name="TextBox 251"/>
           <p:cNvSpPr txBox="1"/>
           <p:nvPr/>
         </p:nvSpPr>
         <p:spPr>
           <a:xfrm>
-            <a:off x="640080" y="4669536"/>
+            <a:off x="640080" y="5406136"/>
             <a:ext cx="10881360" cy="457200"/>
           </a:xfrm>
           <a:prstGeom prst="rect">
@@ -25236,14 +25479,14 @@
                 <a:latin typeface="Segoe UI Light"/>
                 <a:cs typeface="Segoe UI Light"/>
               </a:rPr>
-              <a:t>✓  Three chunks come back, each with a similarity score</a:t>
-            </a:r>
-          </a:p>
-        </p:txBody>
-      </p:sp>
-      <p:sp>
-        <p:nvSpPr>
-          <p:cNvPr id="259" name="TextBox 259"/>
+              <a:t>✓  One vector and one record per chunk, not per page</a:t>
+            </a:r>
+          </a:p>
+        </p:txBody>
+      </p:sp>
+      <p:sp>
+        <p:nvSpPr>
+          <p:cNvPr id="252" name="TextBox 252"/>
           <p:cNvSpPr txBox="1"/>
           <p:nvPr/>
         </p:nvSpPr>
@@ -25309,7 +25552,7 @@
       </p:grpSpPr>
       <p:sp>
         <p:nvSpPr>
-          <p:cNvPr id="260" name="SlideNum 260"/>
+          <p:cNvPr id="253" name="SlideNum 253"/>
           <p:cNvSpPr txBox="1"/>
           <p:nvPr/>
         </p:nvSpPr>
@@ -25353,7 +25596,7 @@
       </p:sp>
       <p:sp>
         <p:nvSpPr>
-          <p:cNvPr id="261" name="Pill 261"/>
+          <p:cNvPr id="254" name="Pill 254"/>
           <p:cNvSpPr/>
           <p:nvPr/>
         </p:nvSpPr>
@@ -25397,7 +25640,7 @@
       </p:sp>
       <p:sp>
         <p:nvSpPr>
-          <p:cNvPr id="262" name="TextBox 262"/>
+          <p:cNvPr id="255" name="TextBox 255"/>
           <p:cNvSpPr txBox="1"/>
           <p:nvPr/>
         </p:nvSpPr>
@@ -25431,21 +25674,21 @@
                 <a:latin typeface="Tw Cen MT"/>
                 <a:cs typeface="Tw Cen MT"/>
               </a:rPr>
-              <a:t>BUILD THE AUGMENTED PROMPT</a:t>
-            </a:r>
-          </a:p>
-        </p:txBody>
-      </p:sp>
-      <p:sp>
-        <p:nvSpPr>
-          <p:cNvPr id="263" name="Card 263"/>
+              <a:t>QUERY: SEARCH THE STORE</a:t>
+            </a:r>
+          </a:p>
+        </p:txBody>
+      </p:sp>
+      <p:sp>
+        <p:nvSpPr>
+          <p:cNvPr id="256" name="Card 256"/>
           <p:cNvSpPr/>
           <p:nvPr/>
         </p:nvSpPr>
         <p:spPr>
           <a:xfrm>
             <a:off x="640080" y="1691640"/>
-            <a:ext cx="10881360" cy="3881628"/>
+            <a:ext cx="10881360" cy="2776728"/>
           </a:xfrm>
           <a:prstGeom prst="roundRect">
             <a:avLst>
@@ -25469,14 +25712,14 @@
       </p:sp>
       <p:sp>
         <p:nvSpPr>
-          <p:cNvPr id="264" name="TextBox 264"/>
+          <p:cNvPr id="257" name="TextBox 257"/>
           <p:cNvSpPr txBox="1"/>
           <p:nvPr/>
         </p:nvSpPr>
         <p:spPr>
           <a:xfrm>
             <a:off x="960120" y="1975104"/>
-            <a:ext cx="10332720" cy="3314700"/>
+            <a:ext cx="10332720" cy="2209800"/>
           </a:xfrm>
           <a:prstGeom prst="rect">
             <a:avLst/>
@@ -25503,7 +25746,7 @@
                 <a:latin typeface="Consolas"/>
                 <a:cs typeface="Consolas"/>
               </a:rPr>
-              <a:t>var context = new StringBuilder();</a:t>
+              <a:t>Console.Write("Question: ");</a:t>
             </a:r>
           </a:p>
           <a:p>
@@ -25521,8 +25764,17 @@
                 <a:latin typeface="Consolas"/>
                 <a:cs typeface="Consolas"/>
               </a:rPr>
-              <a:t>await foreach (var hit in hits)</a:t>
-            </a:r>
+              <a:t>var question = Console.ReadLine()!;</a:t>
+            </a:r>
+          </a:p>
+          <a:p>
+            <a:pPr algn="l">
+              <a:lnSpc>
+                <a:spcPct val="118000"/>
+              </a:lnSpc>
+              <a:buNone/>
+            </a:pPr>
+            <a:endParaRPr lang="en-US" sz="2000" dirty="0"/>
           </a:p>
           <a:p>
             <a:pPr algn="l">
@@ -25539,7 +25791,7 @@
                 <a:latin typeface="Consolas"/>
                 <a:cs typeface="Consolas"/>
               </a:rPr>
-              <a:t>    context.AppendLine(hit.Record.Text);</a:t>
+              <a:t>var qv = await embedder.GenerateAsync(question);</a:t>
             </a:r>
           </a:p>
           <a:p>
@@ -25566,92 +25818,20 @@
                 <a:latin typeface="Consolas"/>
                 <a:cs typeface="Consolas"/>
               </a:rPr>
-              <a:t>var prompt = $"""</a:t>
-            </a:r>
-          </a:p>
-          <a:p>
-            <a:pPr algn="l">
-              <a:lnSpc>
-                <a:spcPct val="118000"/>
-              </a:lnSpc>
-              <a:buNone/>
-            </a:pPr>
-            <a:r>
-              <a:rPr lang="en-US" sz="2000" b="0" dirty="0">
-                <a:solidFill>
-                  <a:srgbClr val="FFFFFF"/>
-                </a:solidFill>
-                <a:latin typeface="Consolas"/>
-                <a:cs typeface="Consolas"/>
-              </a:rPr>
-              <a:t>    Answer using ONLY the context below.</a:t>
-            </a:r>
-          </a:p>
-          <a:p>
-            <a:pPr algn="l">
-              <a:lnSpc>
-                <a:spcPct val="118000"/>
-              </a:lnSpc>
-              <a:buNone/>
-            </a:pPr>
-            <a:r>
-              <a:rPr lang="en-US" sz="2000" b="0" dirty="0">
-                <a:solidFill>
-                  <a:srgbClr val="FFFFFF"/>
-                </a:solidFill>
-                <a:latin typeface="Consolas"/>
-                <a:cs typeface="Consolas"/>
-              </a:rPr>
-              <a:t>    CONTEXT:  {context}</a:t>
-            </a:r>
-          </a:p>
-          <a:p>
-            <a:pPr algn="l">
-              <a:lnSpc>
-                <a:spcPct val="118000"/>
-              </a:lnSpc>
-              <a:buNone/>
-            </a:pPr>
-            <a:r>
-              <a:rPr lang="en-US" sz="2000" b="0" dirty="0">
-                <a:solidFill>
-                  <a:srgbClr val="FFFFFF"/>
-                </a:solidFill>
-                <a:latin typeface="Consolas"/>
-                <a:cs typeface="Consolas"/>
-              </a:rPr>
-              <a:t>    QUESTION: {question}</a:t>
-            </a:r>
-          </a:p>
-          <a:p>
-            <a:pPr algn="l">
-              <a:lnSpc>
-                <a:spcPct val="118000"/>
-              </a:lnSpc>
-              <a:buNone/>
-            </a:pPr>
-            <a:r>
-              <a:rPr lang="en-US" sz="2000" b="0" dirty="0">
-                <a:solidFill>
-                  <a:srgbClr val="FFFFFF"/>
-                </a:solidFill>
-                <a:latin typeface="Consolas"/>
-                <a:cs typeface="Consolas"/>
-              </a:rPr>
-              <a:t>    """;</a:t>
-            </a:r>
-          </a:p>
-        </p:txBody>
-      </p:sp>
-      <p:sp>
-        <p:nvSpPr>
-          <p:cNvPr id="265" name="TextBox 265"/>
+              <a:t>var hits = pages.SearchAsync(qv.Vector, top: 3);</a:t>
+            </a:r>
+          </a:p>
+        </p:txBody>
+      </p:sp>
+      <p:sp>
+        <p:nvSpPr>
+          <p:cNvPr id="258" name="TextBox 258"/>
           <p:cNvSpPr txBox="1"/>
           <p:nvPr/>
         </p:nvSpPr>
         <p:spPr>
           <a:xfrm>
-            <a:off x="640080" y="5774436"/>
+            <a:off x="640080" y="4669536"/>
             <a:ext cx="10881360" cy="457200"/>
           </a:xfrm>
           <a:prstGeom prst="rect">
@@ -25679,14 +25859,14 @@
                 <a:latin typeface="Segoe UI Light"/>
                 <a:cs typeface="Segoe UI Light"/>
               </a:rPr>
-              <a:t>✓  This prompt is the whole trick — print it and read it</a:t>
-            </a:r>
-          </a:p>
-        </p:txBody>
-      </p:sp>
-      <p:sp>
-        <p:nvSpPr>
-          <p:cNvPr id="266" name="TextBox 266"/>
+              <a:t>✓  Three chunks come back, each with a similarity score</a:t>
+            </a:r>
+          </a:p>
+        </p:txBody>
+      </p:sp>
+      <p:sp>
+        <p:nvSpPr>
+          <p:cNvPr id="259" name="TextBox 259"/>
           <p:cNvSpPr txBox="1"/>
           <p:nvPr/>
         </p:nvSpPr>
@@ -26050,7 +26230,7 @@
       </p:grpSpPr>
       <p:sp>
         <p:nvSpPr>
-          <p:cNvPr id="267" name="SlideNum 267"/>
+          <p:cNvPr id="260" name="SlideNum 260"/>
           <p:cNvSpPr txBox="1"/>
           <p:nvPr/>
         </p:nvSpPr>
@@ -26094,7 +26274,7 @@
       </p:sp>
       <p:sp>
         <p:nvSpPr>
-          <p:cNvPr id="268" name="Pill 268"/>
+          <p:cNvPr id="261" name="Pill 261"/>
           <p:cNvSpPr/>
           <p:nvPr/>
         </p:nvSpPr>
@@ -26138,7 +26318,7 @@
       </p:sp>
       <p:sp>
         <p:nvSpPr>
-          <p:cNvPr id="269" name="TextBox 269"/>
+          <p:cNvPr id="262" name="TextBox 262"/>
           <p:cNvSpPr txBox="1"/>
           <p:nvPr/>
         </p:nvSpPr>
@@ -26172,21 +26352,21 @@
                 <a:latin typeface="Tw Cen MT"/>
                 <a:cs typeface="Tw Cen MT"/>
               </a:rPr>
-              <a:t>GENERATE THE ANSWER</a:t>
-            </a:r>
-          </a:p>
-        </p:txBody>
-      </p:sp>
-      <p:sp>
-        <p:nvSpPr>
-          <p:cNvPr id="270" name="Card 270"/>
+              <a:t>BUILD THE AUGMENTED PROMPT</a:t>
+            </a:r>
+          </a:p>
+        </p:txBody>
+      </p:sp>
+      <p:sp>
+        <p:nvSpPr>
+          <p:cNvPr id="263" name="Card 263"/>
           <p:cNvSpPr/>
           <p:nvPr/>
         </p:nvSpPr>
         <p:spPr>
           <a:xfrm>
             <a:off x="640080" y="1691640"/>
-            <a:ext cx="10881360" cy="1671828"/>
+            <a:ext cx="10881360" cy="3881628"/>
           </a:xfrm>
           <a:prstGeom prst="roundRect">
             <a:avLst>
@@ -26210,14 +26390,14 @@
       </p:sp>
       <p:sp>
         <p:nvSpPr>
-          <p:cNvPr id="271" name="TextBox 271"/>
+          <p:cNvPr id="264" name="TextBox 264"/>
           <p:cNvSpPr txBox="1"/>
           <p:nvPr/>
         </p:nvSpPr>
         <p:spPr>
           <a:xfrm>
             <a:off x="960120" y="1975104"/>
-            <a:ext cx="10332720" cy="1104900"/>
+            <a:ext cx="10332720" cy="3314700"/>
           </a:xfrm>
           <a:prstGeom prst="rect">
             <a:avLst/>
@@ -26244,7 +26424,43 @@
                 <a:latin typeface="Consolas"/>
                 <a:cs typeface="Consolas"/>
               </a:rPr>
-              <a:t>var reply = await chat.GetResponseAsync(prompt);</a:t>
+              <a:t>var context = new StringBuilder();</a:t>
+            </a:r>
+          </a:p>
+          <a:p>
+            <a:pPr algn="l">
+              <a:lnSpc>
+                <a:spcPct val="118000"/>
+              </a:lnSpc>
+              <a:buNone/>
+            </a:pPr>
+            <a:r>
+              <a:rPr lang="en-US" sz="2000" b="0" dirty="0">
+                <a:solidFill>
+                  <a:srgbClr val="FFFFFF"/>
+                </a:solidFill>
+                <a:latin typeface="Consolas"/>
+                <a:cs typeface="Consolas"/>
+              </a:rPr>
+              <a:t>await foreach (var hit in hits)</a:t>
+            </a:r>
+          </a:p>
+          <a:p>
+            <a:pPr algn="l">
+              <a:lnSpc>
+                <a:spcPct val="118000"/>
+              </a:lnSpc>
+              <a:buNone/>
+            </a:pPr>
+            <a:r>
+              <a:rPr lang="en-US" sz="2000" b="0" dirty="0">
+                <a:solidFill>
+                  <a:srgbClr val="FFFFFF"/>
+                </a:solidFill>
+                <a:latin typeface="Consolas"/>
+                <a:cs typeface="Consolas"/>
+              </a:rPr>
+              <a:t>    context.AppendLine(hit.Record.Text);</a:t>
             </a:r>
           </a:p>
           <a:p>
@@ -26271,20 +26487,92 @@
                 <a:latin typeface="Consolas"/>
                 <a:cs typeface="Consolas"/>
               </a:rPr>
-              <a:t>Console.WriteLine(reply.Text);</a:t>
-            </a:r>
-          </a:p>
-        </p:txBody>
-      </p:sp>
-      <p:sp>
-        <p:nvSpPr>
-          <p:cNvPr id="272" name="TextBox 272"/>
+              <a:t>var prompt = $"""</a:t>
+            </a:r>
+          </a:p>
+          <a:p>
+            <a:pPr algn="l">
+              <a:lnSpc>
+                <a:spcPct val="118000"/>
+              </a:lnSpc>
+              <a:buNone/>
+            </a:pPr>
+            <a:r>
+              <a:rPr lang="en-US" sz="2000" b="0" dirty="0">
+                <a:solidFill>
+                  <a:srgbClr val="FFFFFF"/>
+                </a:solidFill>
+                <a:latin typeface="Consolas"/>
+                <a:cs typeface="Consolas"/>
+              </a:rPr>
+              <a:t>    Answer using ONLY the context below.</a:t>
+            </a:r>
+          </a:p>
+          <a:p>
+            <a:pPr algn="l">
+              <a:lnSpc>
+                <a:spcPct val="118000"/>
+              </a:lnSpc>
+              <a:buNone/>
+            </a:pPr>
+            <a:r>
+              <a:rPr lang="en-US" sz="2000" b="0" dirty="0">
+                <a:solidFill>
+                  <a:srgbClr val="FFFFFF"/>
+                </a:solidFill>
+                <a:latin typeface="Consolas"/>
+                <a:cs typeface="Consolas"/>
+              </a:rPr>
+              <a:t>    CONTEXT:  {context}</a:t>
+            </a:r>
+          </a:p>
+          <a:p>
+            <a:pPr algn="l">
+              <a:lnSpc>
+                <a:spcPct val="118000"/>
+              </a:lnSpc>
+              <a:buNone/>
+            </a:pPr>
+            <a:r>
+              <a:rPr lang="en-US" sz="2000" b="0" dirty="0">
+                <a:solidFill>
+                  <a:srgbClr val="FFFFFF"/>
+                </a:solidFill>
+                <a:latin typeface="Consolas"/>
+                <a:cs typeface="Consolas"/>
+              </a:rPr>
+              <a:t>    QUESTION: {question}</a:t>
+            </a:r>
+          </a:p>
+          <a:p>
+            <a:pPr algn="l">
+              <a:lnSpc>
+                <a:spcPct val="118000"/>
+              </a:lnSpc>
+              <a:buNone/>
+            </a:pPr>
+            <a:r>
+              <a:rPr lang="en-US" sz="2000" b="0" dirty="0">
+                <a:solidFill>
+                  <a:srgbClr val="FFFFFF"/>
+                </a:solidFill>
+                <a:latin typeface="Consolas"/>
+                <a:cs typeface="Consolas"/>
+              </a:rPr>
+              <a:t>    """;</a:t>
+            </a:r>
+          </a:p>
+        </p:txBody>
+      </p:sp>
+      <p:sp>
+        <p:nvSpPr>
+          <p:cNvPr id="265" name="TextBox 265"/>
           <p:cNvSpPr txBox="1"/>
           <p:nvPr/>
         </p:nvSpPr>
         <p:spPr>
           <a:xfrm>
-            <a:off x="640080" y="3564636"/>
+            <a:off x="640080" y="5774436"/>
             <a:ext cx="10881360" cy="457200"/>
           </a:xfrm>
           <a:prstGeom prst="rect">
@@ -26312,55 +26600,14 @@
                 <a:latin typeface="Segoe UI Light"/>
                 <a:cs typeface="Segoe UI Light"/>
               </a:rPr>
-              <a:t>✓  The model answers from the pages, not from memory</a:t>
-            </a:r>
-          </a:p>
-        </p:txBody>
-      </p:sp>
-      <p:sp>
-        <p:nvSpPr>
-          <p:cNvPr id="273" name="TextBox 273"/>
-          <p:cNvSpPr txBox="1"/>
-          <p:nvPr/>
-        </p:nvSpPr>
-        <p:spPr>
-          <a:xfrm>
-            <a:off x="640080" y="4021836"/>
-            <a:ext cx="10881360" cy="411480"/>
-          </a:xfrm>
-          <a:prstGeom prst="rect">
-            <a:avLst/>
-          </a:prstGeom>
-          <a:noFill/>
-        </p:spPr>
-        <p:txBody>
-          <a:bodyPr wrap="square" lIns="0" tIns="0" rIns="0" bIns="0" anchor="t">
-            <a:noAutofit/>
-          </a:bodyPr>
-          <a:lstStyle/>
-          <a:p>
-            <a:pPr algn="l">
-              <a:lnSpc>
-                <a:spcPct val="115000"/>
-              </a:lnSpc>
-              <a:buNone/>
-            </a:pPr>
-            <a:r>
-              <a:rPr lang="en-US" sz="1800" b="0" dirty="0">
-                <a:solidFill>
-                  <a:srgbClr val="A8BBDD"/>
-                </a:solidFill>
-                <a:latin typeface="Segoe UI Light"/>
-                <a:cs typeface="Segoe UI Light"/>
-              </a:rPr>
-              <a:t>Nothing here is RAG-specific — it is an ordinary chat call.</a:t>
-            </a:r>
-          </a:p>
-        </p:txBody>
-      </p:sp>
-      <p:sp>
-        <p:nvSpPr>
-          <p:cNvPr id="274" name="TextBox 274"/>
+              <a:t>✓  This prompt is the whole trick — print it and read it</a:t>
+            </a:r>
+          </a:p>
+        </p:txBody>
+      </p:sp>
+      <p:sp>
+        <p:nvSpPr>
+          <p:cNvPr id="266" name="TextBox 266"/>
           <p:cNvSpPr txBox="1"/>
           <p:nvPr/>
         </p:nvSpPr>
@@ -26426,7 +26673,7 @@
       </p:grpSpPr>
       <p:sp>
         <p:nvSpPr>
-          <p:cNvPr id="275" name="SlideNum 275"/>
+          <p:cNvPr id="267" name="SlideNum 267"/>
           <p:cNvSpPr txBox="1"/>
           <p:nvPr/>
         </p:nvSpPr>
@@ -26470,13 +26717,57 @@
       </p:sp>
       <p:sp>
         <p:nvSpPr>
-          <p:cNvPr id="276" name="TextBox 276"/>
+          <p:cNvPr id="268" name="Pill 268"/>
+          <p:cNvSpPr/>
+          <p:nvPr/>
+        </p:nvSpPr>
+        <p:spPr>
+          <a:xfrm>
+            <a:off x="640080" y="347472"/>
+            <a:ext cx="1417320" cy="384048"/>
+          </a:xfrm>
+          <a:prstGeom prst="roundRect">
+            <a:avLst>
+              <a:gd name="adj" fmla="val 50000"/>
+            </a:avLst>
+          </a:prstGeom>
+          <a:solidFill>
+            <a:srgbClr val="F6A6F4"/>
+          </a:solidFill>
+          <a:ln>
+            <a:noFill/>
+          </a:ln>
+        </p:spPr>
+        <p:txBody>
+          <a:bodyPr lIns="45720" tIns="0" rIns="45720" bIns="0" anchor="ctr">
+            <a:noAutofit/>
+          </a:bodyPr>
+          <a:lstStyle/>
+          <a:p>
+            <a:pPr algn="ctr">
+              <a:buNone/>
+            </a:pPr>
+            <a:r>
+              <a:rPr lang="en-US" sz="1700" b="1" dirty="0">
+                <a:solidFill>
+                  <a:srgbClr val="102858"/>
+                </a:solidFill>
+                <a:latin typeface="Segoe UI Light"/>
+              </a:rPr>
+              <a:t>STEP 12</a:t>
+            </a:r>
+          </a:p>
+        </p:txBody>
+      </p:sp>
+      <p:sp>
+        <p:nvSpPr>
+          <p:cNvPr id="269" name="TextBox 269"/>
           <p:cNvSpPr txBox="1"/>
           <p:nvPr/>
         </p:nvSpPr>
         <p:spPr>
           <a:xfrm>
-            <a:off x="640080" y="384048"/>
+            <a:off x="640080" y="841248"/>
             <a:ext cx="10881360" cy="868680"/>
           </a:xfrm>
           <a:prstGeom prst="rect">
@@ -26497,28 +26788,28 @@
               <a:buNone/>
             </a:pPr>
             <a:r>
-              <a:rPr lang="en-US" sz="3200" b="1" dirty="0">
+              <a:rPr lang="en-US" sz="3000" b="1" dirty="0">
                 <a:solidFill>
                   <a:srgbClr val="FFFFFF"/>
                 </a:solidFill>
                 <a:latin typeface="Tw Cen MT"/>
                 <a:cs typeface="Tw Cen MT"/>
               </a:rPr>
-              <a:t>RUN IT</a:t>
-            </a:r>
-          </a:p>
-        </p:txBody>
-      </p:sp>
-      <p:sp>
-        <p:nvSpPr>
-          <p:cNvPr id="277" name="Card 277"/>
+              <a:t>GENERATE THE ANSWER</a:t>
+            </a:r>
+          </a:p>
+        </p:txBody>
+      </p:sp>
+      <p:sp>
+        <p:nvSpPr>
+          <p:cNvPr id="270" name="Card 270"/>
           <p:cNvSpPr/>
           <p:nvPr/>
         </p:nvSpPr>
         <p:spPr>
           <a:xfrm>
-            <a:off x="640080" y="1481328"/>
-            <a:ext cx="10881360" cy="3877056"/>
+            <a:off x="640080" y="1691640"/>
+            <a:ext cx="10881360" cy="1671828"/>
           </a:xfrm>
           <a:prstGeom prst="roundRect">
             <a:avLst>
@@ -26526,7 +26817,7 @@
             </a:avLst>
           </a:prstGeom>
           <a:solidFill>
-            <a:srgbClr val="071433"/>
+            <a:srgbClr val="0A1C42"/>
           </a:solidFill>
           <a:ln>
             <a:noFill/>
@@ -26542,14 +26833,14 @@
       </p:sp>
       <p:sp>
         <p:nvSpPr>
-          <p:cNvPr id="278" name="TextBox 278"/>
+          <p:cNvPr id="271" name="TextBox 271"/>
           <p:cNvSpPr txBox="1"/>
           <p:nvPr/>
         </p:nvSpPr>
         <p:spPr>
           <a:xfrm>
-            <a:off x="960120" y="1764792"/>
-            <a:ext cx="10332720" cy="3310128"/>
+            <a:off x="960120" y="1975104"/>
+            <a:ext cx="10332720" cy="1104900"/>
           </a:xfrm>
           <a:prstGeom prst="rect">
             <a:avLst/>
@@ -26569,14 +26860,14 @@
               <a:buNone/>
             </a:pPr>
             <a:r>
-              <a:rPr lang="en-US" sz="1800" b="0" dirty="0">
-                <a:solidFill>
-                  <a:srgbClr val="64DFED"/>
+              <a:rPr lang="en-US" sz="2000" b="0" dirty="0">
+                <a:solidFill>
+                  <a:srgbClr val="FFFFFF"/>
                 </a:solidFill>
                 <a:latin typeface="Consolas"/>
                 <a:cs typeface="Consolas"/>
               </a:rPr>
-              <a:t>&gt; dotnet run</a:t>
+              <a:t>var reply = await chat.GetResponseAsync(prompt);</a:t>
             </a:r>
           </a:p>
           <a:p>
@@ -26586,7 +26877,7 @@
               </a:lnSpc>
               <a:buNone/>
             </a:pPr>
-            <a:endParaRPr lang="en-US" sz="1800" dirty="0"/>
+            <a:endParaRPr lang="en-US" sz="2000" dirty="0"/>
           </a:p>
           <a:p>
             <a:pPr algn="l">
@@ -26596,118 +26887,28 @@
               <a:buNone/>
             </a:pPr>
             <a:r>
-              <a:rPr lang="en-US" sz="1800" b="0" dirty="0">
+              <a:rPr lang="en-US" sz="2000" b="0" dirty="0">
                 <a:solidFill>
                   <a:srgbClr val="FFFFFF"/>
                 </a:solidFill>
                 <a:latin typeface="Consolas"/>
                 <a:cs typeface="Consolas"/>
               </a:rPr>
-              <a:t>Ingesting 8 pages from docs/ ...</a:t>
-            </a:r>
-          </a:p>
-          <a:p>
-            <a:pPr algn="l">
-              <a:lnSpc>
-                <a:spcPct val="118000"/>
-              </a:lnSpc>
-              <a:buNone/>
-            </a:pPr>
-            <a:r>
-              <a:rPr lang="en-US" sz="1800" b="0" dirty="0">
-                <a:solidFill>
-                  <a:srgbClr val="FFFFFF"/>
-                </a:solidFill>
-                <a:latin typeface="Consolas"/>
-                <a:cs typeface="Consolas"/>
-              </a:rPr>
-              <a:t>  Indexed 34 chunks.</a:t>
-            </a:r>
-          </a:p>
-          <a:p>
-            <a:pPr algn="l">
-              <a:lnSpc>
-                <a:spcPct val="118000"/>
-              </a:lnSpc>
-              <a:buNone/>
-            </a:pPr>
-            <a:endParaRPr lang="en-US" sz="1800" dirty="0"/>
-          </a:p>
-          <a:p>
-            <a:pPr algn="l">
-              <a:lnSpc>
-                <a:spcPct val="118000"/>
-              </a:lnSpc>
-              <a:buNone/>
-            </a:pPr>
-            <a:r>
-              <a:rPr lang="en-US" sz="1800" b="0" dirty="0">
-                <a:solidFill>
-                  <a:srgbClr val="FFFFFF"/>
-                </a:solidFill>
-                <a:latin typeface="Consolas"/>
-                <a:cs typeface="Consolas"/>
-              </a:rPr>
-              <a:t>Question: How do I book an appointment?</a:t>
-            </a:r>
-          </a:p>
-          <a:p>
-            <a:pPr algn="l">
-              <a:lnSpc>
-                <a:spcPct val="118000"/>
-              </a:lnSpc>
-              <a:buNone/>
-            </a:pPr>
-            <a:endParaRPr lang="en-US" sz="1800" dirty="0"/>
-          </a:p>
-          <a:p>
-            <a:pPr algn="l">
-              <a:lnSpc>
-                <a:spcPct val="118000"/>
-              </a:lnSpc>
-              <a:buNone/>
-            </a:pPr>
-            <a:r>
-              <a:rPr lang="en-US" sz="1800" b="0" dirty="0">
-                <a:solidFill>
-                  <a:srgbClr val="FFFFFF"/>
-                </a:solidFill>
-                <a:latin typeface="Consolas"/>
-                <a:cs typeface="Consolas"/>
-              </a:rPr>
-              <a:t>Answer: Through the website, the mobile app, or</a:t>
-            </a:r>
-          </a:p>
-          <a:p>
-            <a:pPr algn="l">
-              <a:lnSpc>
-                <a:spcPct val="118000"/>
-              </a:lnSpc>
-              <a:buNone/>
-            </a:pPr>
-            <a:r>
-              <a:rPr lang="en-US" sz="1800" b="0" dirty="0">
-                <a:solidFill>
-                  <a:srgbClr val="FFFFFF"/>
-                </a:solidFill>
-                <a:latin typeface="Consolas"/>
-                <a:cs typeface="Consolas"/>
-              </a:rPr>
-              <a:t>by calling the service centre.  [source: page3.md]</a:t>
-            </a:r>
-          </a:p>
-        </p:txBody>
-      </p:sp>
-      <p:sp>
-        <p:nvSpPr>
-          <p:cNvPr id="279" name="TextBox 279"/>
+              <a:t>Console.WriteLine(reply.Text);</a:t>
+            </a:r>
+          </a:p>
+        </p:txBody>
+      </p:sp>
+      <p:sp>
+        <p:nvSpPr>
+          <p:cNvPr id="272" name="TextBox 272"/>
           <p:cNvSpPr txBox="1"/>
           <p:nvPr/>
         </p:nvSpPr>
         <p:spPr>
           <a:xfrm>
-            <a:off x="640080" y="5559552"/>
-            <a:ext cx="10881360" cy="502920"/>
+            <a:off x="640080" y="3564636"/>
+            <a:ext cx="10881360" cy="457200"/>
           </a:xfrm>
           <a:prstGeom prst="rect">
             <a:avLst/>
@@ -26727,21 +26928,62 @@
               <a:buNone/>
             </a:pPr>
             <a:r>
-              <a:rPr lang="en-US" sz="2000" b="0" dirty="0">
-                <a:solidFill>
-                  <a:srgbClr val="F6A6F4"/>
+              <a:rPr lang="en-US" sz="1900" b="0" dirty="0">
+                <a:solidFill>
+                  <a:srgbClr val="64DFED"/>
                 </a:solidFill>
                 <a:latin typeface="Segoe UI Light"/>
                 <a:cs typeface="Segoe UI Light"/>
               </a:rPr>
-              <a:t>Now ask something the pages do not cover — and watch it decline.</a:t>
-            </a:r>
-          </a:p>
-        </p:txBody>
-      </p:sp>
-      <p:sp>
-        <p:nvSpPr>
-          <p:cNvPr id="280" name="TextBox 280"/>
+              <a:t>✓  The model answers from the pages, not from memory</a:t>
+            </a:r>
+          </a:p>
+        </p:txBody>
+      </p:sp>
+      <p:sp>
+        <p:nvSpPr>
+          <p:cNvPr id="273" name="TextBox 273"/>
+          <p:cNvSpPr txBox="1"/>
+          <p:nvPr/>
+        </p:nvSpPr>
+        <p:spPr>
+          <a:xfrm>
+            <a:off x="640080" y="4021836"/>
+            <a:ext cx="10881360" cy="411480"/>
+          </a:xfrm>
+          <a:prstGeom prst="rect">
+            <a:avLst/>
+          </a:prstGeom>
+          <a:noFill/>
+        </p:spPr>
+        <p:txBody>
+          <a:bodyPr wrap="square" lIns="0" tIns="0" rIns="0" bIns="0" anchor="t">
+            <a:noAutofit/>
+          </a:bodyPr>
+          <a:lstStyle/>
+          <a:p>
+            <a:pPr algn="l">
+              <a:lnSpc>
+                <a:spcPct val="115000"/>
+              </a:lnSpc>
+              <a:buNone/>
+            </a:pPr>
+            <a:r>
+              <a:rPr lang="en-US" sz="1800" b="0" dirty="0">
+                <a:solidFill>
+                  <a:srgbClr val="A8BBDD"/>
+                </a:solidFill>
+                <a:latin typeface="Segoe UI Light"/>
+                <a:cs typeface="Segoe UI Light"/>
+              </a:rPr>
+              <a:t>Nothing here is RAG-specific — it is an ordinary chat call.</a:t>
+            </a:r>
+          </a:p>
+        </p:txBody>
+      </p:sp>
+      <p:sp>
+        <p:nvSpPr>
+          <p:cNvPr id="274" name="TextBox 274"/>
           <p:cNvSpPr txBox="1"/>
           <p:nvPr/>
         </p:nvSpPr>
@@ -26807,86 +27049,340 @@
       </p:grpSpPr>
       <p:sp>
         <p:nvSpPr>
-          <p:cNvPr id="2" name="Title 1">
-            <a:extLst>
-              <a:ext uri="{FF2B5EF4-FFF2-40B4-BE49-F238E27FC236}">
-                <a16:creationId xmlns:a16="http://schemas.microsoft.com/office/drawing/2014/main" id="{48C5BC92-868A-26B2-CBC0-C9D94E65F1A4}"/>
-              </a:ext>
-            </a:extLst>
-          </p:cNvPr>
-          <p:cNvSpPr>
-            <a:spLocks noGrp="1"/>
-          </p:cNvSpPr>
-          <p:nvPr>
-            <p:ph type="ctrTitle"/>
-          </p:nvPr>
-        </p:nvSpPr>
-        <p:spPr/>
-        <p:txBody>
-          <a:bodyPr>
+          <p:cNvPr id="275" name="SlideNum 275"/>
+          <p:cNvSpPr txBox="1"/>
+          <p:nvPr/>
+        </p:nvSpPr>
+        <p:spPr>
+          <a:xfrm>
+            <a:off x="411480" y="256032"/>
+            <a:ext cx="731520" cy="320040"/>
+          </a:xfrm>
+          <a:prstGeom prst="rect">
+            <a:avLst/>
+          </a:prstGeom>
+          <a:noFill/>
+        </p:spPr>
+        <p:txBody>
+          <a:bodyPr wrap="none" lIns="0" tIns="0" rIns="0" bIns="0"/>
+          <a:lstStyle/>
+          <a:p>
+            <a:pPr>
+              <a:buNone/>
+            </a:pPr>
+            <a:fld id="{294A09A9-5501-47C1-A89A-A340965A2BE2}" type="slidenum">
+              <a:rPr lang="en-US" sz="1400" dirty="0">
+                <a:solidFill>
+                  <a:srgbClr val="A8BBDD"/>
+                </a:solidFill>
+                <a:latin typeface="Segoe UI Light"/>
+              </a:rPr>
+              <a:pPr>
+                <a:buNone/>
+              </a:pPr>
+              <a:t>32</a:t>
+            </a:fld>
+            <a:endParaRPr lang="en-US" sz="1400" dirty="0">
+              <a:solidFill>
+                <a:srgbClr val="A8BBDD"/>
+              </a:solidFill>
+              <a:latin typeface="Segoe UI Light"/>
+            </a:endParaRPr>
+          </a:p>
+        </p:txBody>
+      </p:sp>
+      <p:sp>
+        <p:nvSpPr>
+          <p:cNvPr id="276" name="TextBox 276"/>
+          <p:cNvSpPr txBox="1"/>
+          <p:nvPr/>
+        </p:nvSpPr>
+        <p:spPr>
+          <a:xfrm>
+            <a:off x="640080" y="384048"/>
+            <a:ext cx="10881360" cy="868680"/>
+          </a:xfrm>
+          <a:prstGeom prst="rect">
+            <a:avLst/>
+          </a:prstGeom>
+          <a:noFill/>
+        </p:spPr>
+        <p:txBody>
+          <a:bodyPr wrap="square" lIns="0" tIns="0" rIns="0" bIns="0" anchor="t">
             <a:noAutofit/>
           </a:bodyPr>
           <a:lstStyle/>
           <a:p>
-            <a:pPr algn="ctr">
+            <a:pPr algn="l">
               <a:lnSpc>
                 <a:spcPct val="100000"/>
               </a:lnSpc>
               <a:buNone/>
             </a:pPr>
             <a:r>
-              <a:rPr lang="en-US" sz="4000" b="1" dirty="0">
+              <a:rPr lang="en-US" sz="3200" b="1" dirty="0">
                 <a:solidFill>
                   <a:srgbClr val="FFFFFF"/>
                 </a:solidFill>
                 <a:latin typeface="Tw Cen MT"/>
                 <a:cs typeface="Tw Cen MT"/>
               </a:rPr>
-              <a:t>WHAT JUST HAPPENED</a:t>
-            </a:r>
-          </a:p>
-        </p:txBody>
-      </p:sp>
-      <p:sp>
-        <p:nvSpPr>
-          <p:cNvPr id="3" name="Subtitle 2">
-            <a:extLst>
-              <a:ext uri="{FF2B5EF4-FFF2-40B4-BE49-F238E27FC236}">
-                <a16:creationId xmlns:a16="http://schemas.microsoft.com/office/drawing/2014/main" id="{6F9C1627-7A56-025E-482D-E2AB014EDF92}"/>
-              </a:ext>
-            </a:extLst>
-          </p:cNvPr>
-          <p:cNvSpPr>
-            <a:spLocks noGrp="1"/>
-          </p:cNvSpPr>
-          <p:nvPr>
-            <p:ph type="subTitle" idx="1"/>
-          </p:nvPr>
-        </p:nvSpPr>
-        <p:spPr/>
-        <p:txBody>
-          <a:bodyPr>
+              <a:t>RUN IT</a:t>
+            </a:r>
+          </a:p>
+        </p:txBody>
+      </p:sp>
+      <p:sp>
+        <p:nvSpPr>
+          <p:cNvPr id="277" name="Card 277"/>
+          <p:cNvSpPr/>
+          <p:nvPr/>
+        </p:nvSpPr>
+        <p:spPr>
+          <a:xfrm>
+            <a:off x="640080" y="1481328"/>
+            <a:ext cx="10881360" cy="3877056"/>
+          </a:xfrm>
+          <a:prstGeom prst="roundRect">
+            <a:avLst>
+              <a:gd name="adj" fmla="val 3000"/>
+            </a:avLst>
+          </a:prstGeom>
+          <a:solidFill>
+            <a:srgbClr val="071433"/>
+          </a:solidFill>
+          <a:ln>
+            <a:noFill/>
+          </a:ln>
+        </p:spPr>
+        <p:txBody>
+          <a:bodyPr/>
+          <a:lstStyle/>
+          <a:p>
+            <a:endParaRPr lang="en-US"/>
+          </a:p>
+        </p:txBody>
+      </p:sp>
+      <p:sp>
+        <p:nvSpPr>
+          <p:cNvPr id="278" name="TextBox 278"/>
+          <p:cNvSpPr txBox="1"/>
+          <p:nvPr/>
+        </p:nvSpPr>
+        <p:spPr>
+          <a:xfrm>
+            <a:off x="960120" y="1764792"/>
+            <a:ext cx="10332720" cy="3310128"/>
+          </a:xfrm>
+          <a:prstGeom prst="rect">
+            <a:avLst/>
+          </a:prstGeom>
+          <a:noFill/>
+        </p:spPr>
+        <p:txBody>
+          <a:bodyPr wrap="none" lIns="0" tIns="0" rIns="0" bIns="0" anchor="t">
             <a:noAutofit/>
           </a:bodyPr>
           <a:lstStyle/>
           <a:p>
-            <a:pPr algn="ctr">
+            <a:pPr algn="l">
+              <a:lnSpc>
+                <a:spcPct val="118000"/>
+              </a:lnSpc>
+              <a:buNone/>
+            </a:pPr>
+            <a:r>
+              <a:rPr lang="en-US" sz="1800" b="0" dirty="0">
+                <a:solidFill>
+                  <a:srgbClr val="64DFED"/>
+                </a:solidFill>
+                <a:latin typeface="Consolas"/>
+                <a:cs typeface="Consolas"/>
+              </a:rPr>
+              <a:t>&gt; dotnet run</a:t>
+            </a:r>
+          </a:p>
+          <a:p>
+            <a:pPr algn="l">
+              <a:lnSpc>
+                <a:spcPct val="118000"/>
+              </a:lnSpc>
+              <a:buNone/>
+            </a:pPr>
+            <a:endParaRPr lang="en-US" sz="1800" dirty="0"/>
+          </a:p>
+          <a:p>
+            <a:pPr algn="l">
+              <a:lnSpc>
+                <a:spcPct val="118000"/>
+              </a:lnSpc>
+              <a:buNone/>
+            </a:pPr>
+            <a:r>
+              <a:rPr lang="en-US" sz="1800" b="0" dirty="0">
+                <a:solidFill>
+                  <a:srgbClr val="FFFFFF"/>
+                </a:solidFill>
+                <a:latin typeface="Consolas"/>
+                <a:cs typeface="Consolas"/>
+              </a:rPr>
+              <a:t>Ingesting 8 pages from docs/ ...</a:t>
+            </a:r>
+          </a:p>
+          <a:p>
+            <a:pPr algn="l">
+              <a:lnSpc>
+                <a:spcPct val="118000"/>
+              </a:lnSpc>
+              <a:buNone/>
+            </a:pPr>
+            <a:r>
+              <a:rPr lang="en-US" sz="1800" b="0" dirty="0">
+                <a:solidFill>
+                  <a:srgbClr val="FFFFFF"/>
+                </a:solidFill>
+                <a:latin typeface="Consolas"/>
+                <a:cs typeface="Consolas"/>
+              </a:rPr>
+              <a:t>  Indexed 34 chunks.</a:t>
+            </a:r>
+          </a:p>
+          <a:p>
+            <a:pPr algn="l">
+              <a:lnSpc>
+                <a:spcPct val="118000"/>
+              </a:lnSpc>
+              <a:buNone/>
+            </a:pPr>
+            <a:endParaRPr lang="en-US" sz="1800" dirty="0"/>
+          </a:p>
+          <a:p>
+            <a:pPr algn="l">
+              <a:lnSpc>
+                <a:spcPct val="118000"/>
+              </a:lnSpc>
+              <a:buNone/>
+            </a:pPr>
+            <a:r>
+              <a:rPr lang="en-US" sz="1800" b="0" dirty="0">
+                <a:solidFill>
+                  <a:srgbClr val="FFFFFF"/>
+                </a:solidFill>
+                <a:latin typeface="Consolas"/>
+                <a:cs typeface="Consolas"/>
+              </a:rPr>
+              <a:t>Question: How do I book an appointment?</a:t>
+            </a:r>
+          </a:p>
+          <a:p>
+            <a:pPr algn="l">
+              <a:lnSpc>
+                <a:spcPct val="118000"/>
+              </a:lnSpc>
+              <a:buNone/>
+            </a:pPr>
+            <a:endParaRPr lang="en-US" sz="1800" dirty="0"/>
+          </a:p>
+          <a:p>
+            <a:pPr algn="l">
+              <a:lnSpc>
+                <a:spcPct val="118000"/>
+              </a:lnSpc>
+              <a:buNone/>
+            </a:pPr>
+            <a:r>
+              <a:rPr lang="en-US" sz="1800" b="0" dirty="0">
+                <a:solidFill>
+                  <a:srgbClr val="FFFFFF"/>
+                </a:solidFill>
+                <a:latin typeface="Consolas"/>
+                <a:cs typeface="Consolas"/>
+              </a:rPr>
+              <a:t>Answer: Through the website, the mobile app, or</a:t>
+            </a:r>
+          </a:p>
+          <a:p>
+            <a:pPr algn="l">
+              <a:lnSpc>
+                <a:spcPct val="118000"/>
+              </a:lnSpc>
+              <a:buNone/>
+            </a:pPr>
+            <a:r>
+              <a:rPr lang="en-US" sz="1800" b="0" dirty="0">
+                <a:solidFill>
+                  <a:srgbClr val="FFFFFF"/>
+                </a:solidFill>
+                <a:latin typeface="Consolas"/>
+                <a:cs typeface="Consolas"/>
+              </a:rPr>
+              <a:t>by calling the service centre.  [source: page3.md]</a:t>
+            </a:r>
+          </a:p>
+        </p:txBody>
+      </p:sp>
+      <p:sp>
+        <p:nvSpPr>
+          <p:cNvPr id="279" name="TextBox 279"/>
+          <p:cNvSpPr txBox="1"/>
+          <p:nvPr/>
+        </p:nvSpPr>
+        <p:spPr>
+          <a:xfrm>
+            <a:off x="640080" y="5559552"/>
+            <a:ext cx="10881360" cy="502920"/>
+          </a:xfrm>
+          <a:prstGeom prst="rect">
+            <a:avLst/>
+          </a:prstGeom>
+          <a:noFill/>
+        </p:spPr>
+        <p:txBody>
+          <a:bodyPr wrap="square" lIns="0" tIns="0" rIns="0" bIns="0" anchor="t">
+            <a:noAutofit/>
+          </a:bodyPr>
+          <a:lstStyle/>
+          <a:p>
+            <a:pPr algn="l">
               <a:lnSpc>
                 <a:spcPct val="115000"/>
               </a:lnSpc>
               <a:buNone/>
             </a:pPr>
             <a:r>
-              <a:rPr lang="en-US" sz="2200" b="0" dirty="0">
-                <a:solidFill>
-                  <a:srgbClr val="FFFFFF"/>
+              <a:rPr lang="en-US" sz="2000" b="0" dirty="0">
+                <a:solidFill>
+                  <a:srgbClr val="F6A6F4"/>
                 </a:solidFill>
                 <a:latin typeface="Segoe UI Light"/>
                 <a:cs typeface="Segoe UI Light"/>
               </a:rPr>
-              <a:t>We never retrained anything.</a:t>
-            </a:r>
-          </a:p>
+              <a:t>Now ask something the pages do not cover — and watch it decline.</a:t>
+            </a:r>
+          </a:p>
+        </p:txBody>
+      </p:sp>
+      <p:sp>
+        <p:nvSpPr>
+          <p:cNvPr id="280" name="TextBox 280"/>
+          <p:cNvSpPr txBox="1"/>
+          <p:nvPr/>
+        </p:nvSpPr>
+        <p:spPr>
+          <a:xfrm>
+            <a:off x="411480" y="6327648"/>
+            <a:ext cx="5486400" cy="320040"/>
+          </a:xfrm>
+          <a:prstGeom prst="rect">
+            <a:avLst/>
+          </a:prstGeom>
+          <a:noFill/>
+        </p:spPr>
+        <p:txBody>
+          <a:bodyPr wrap="square" lIns="0" tIns="0" rIns="0" bIns="0" anchor="t">
+            <a:noAutofit/>
+          </a:bodyPr>
+          <a:lstStyle/>
           <a:p>
             <a:pPr algn="l">
               <a:lnSpc>
@@ -26894,34 +27390,20 @@
               </a:lnSpc>
               <a:buNone/>
             </a:pPr>
-            <a:endParaRPr lang="en-US" sz="1000" dirty="0"/>
-          </a:p>
-          <a:p>
-            <a:pPr algn="ctr">
-              <a:lnSpc>
-                <a:spcPct val="120000"/>
-              </a:lnSpc>
-              <a:buNone/>
-            </a:pPr>
-            <a:r>
-              <a:rPr lang="en-US" sz="2200" b="0" dirty="0">
-                <a:solidFill>
-                  <a:srgbClr val="FFFFFF"/>
+            <a:r>
+              <a:rPr lang="en-US" sz="1200" b="0" dirty="0">
+                <a:solidFill>
+                  <a:srgbClr val="A8BBDD"/>
                 </a:solidFill>
                 <a:latin typeface="Segoe UI Light"/>
                 <a:cs typeface="Segoe UI Light"/>
               </a:rPr>
-              <a:t>We embedded our pages once, searched them per question, and pasted the winners into the prompt.</a:t>
+              <a:t>RAG  ·  Module 1</a:t>
             </a:r>
           </a:p>
         </p:txBody>
       </p:sp>
     </p:spTree>
-    <p:extLst>
-      <p:ext uri="{BB962C8B-B14F-4D97-AF65-F5344CB8AC3E}">
-        <p14:creationId xmlns:p14="http://schemas.microsoft.com/office/powerpoint/2010/main" val="1958759625"/>
-      </p:ext>
-    </p:extLst>
   </p:cSld>
   <p:clrMapOvr>
     <a:masterClrMapping/>
@@ -26951,6 +27433,147 @@
           <p:cNvPr id="2" name="Title 1">
             <a:extLst>
               <a:ext uri="{FF2B5EF4-FFF2-40B4-BE49-F238E27FC236}">
+                <a16:creationId xmlns:a16="http://schemas.microsoft.com/office/drawing/2014/main" id="{48C5BC92-868A-26B2-CBC0-C9D94E65F1A4}"/>
+              </a:ext>
+            </a:extLst>
+          </p:cNvPr>
+          <p:cNvSpPr>
+            <a:spLocks noGrp="1"/>
+          </p:cNvSpPr>
+          <p:nvPr>
+            <p:ph type="ctrTitle"/>
+          </p:nvPr>
+        </p:nvSpPr>
+        <p:spPr/>
+        <p:txBody>
+          <a:bodyPr>
+            <a:noAutofit/>
+          </a:bodyPr>
+          <a:lstStyle/>
+          <a:p>
+            <a:pPr algn="ctr">
+              <a:lnSpc>
+                <a:spcPct val="100000"/>
+              </a:lnSpc>
+              <a:buNone/>
+            </a:pPr>
+            <a:r>
+              <a:rPr lang="en-US" sz="4000" b="1" dirty="0">
+                <a:solidFill>
+                  <a:srgbClr val="FFFFFF"/>
+                </a:solidFill>
+                <a:latin typeface="Tw Cen MT"/>
+                <a:cs typeface="Tw Cen MT"/>
+              </a:rPr>
+              <a:t>WHAT JUST HAPPENED</a:t>
+            </a:r>
+          </a:p>
+        </p:txBody>
+      </p:sp>
+      <p:sp>
+        <p:nvSpPr>
+          <p:cNvPr id="3" name="Subtitle 2">
+            <a:extLst>
+              <a:ext uri="{FF2B5EF4-FFF2-40B4-BE49-F238E27FC236}">
+                <a16:creationId xmlns:a16="http://schemas.microsoft.com/office/drawing/2014/main" id="{6F9C1627-7A56-025E-482D-E2AB014EDF92}"/>
+              </a:ext>
+            </a:extLst>
+          </p:cNvPr>
+          <p:cNvSpPr>
+            <a:spLocks noGrp="1"/>
+          </p:cNvSpPr>
+          <p:nvPr>
+            <p:ph type="subTitle" idx="1"/>
+          </p:nvPr>
+        </p:nvSpPr>
+        <p:spPr/>
+        <p:txBody>
+          <a:bodyPr>
+            <a:noAutofit/>
+          </a:bodyPr>
+          <a:lstStyle/>
+          <a:p>
+            <a:pPr algn="ctr">
+              <a:lnSpc>
+                <a:spcPct val="115000"/>
+              </a:lnSpc>
+              <a:buNone/>
+            </a:pPr>
+            <a:r>
+              <a:rPr lang="en-US" sz="2200" b="0" dirty="0">
+                <a:solidFill>
+                  <a:srgbClr val="FFFFFF"/>
+                </a:solidFill>
+                <a:latin typeface="Segoe UI Light"/>
+                <a:cs typeface="Segoe UI Light"/>
+              </a:rPr>
+              <a:t>We never retrained anything.</a:t>
+            </a:r>
+          </a:p>
+          <a:p>
+            <a:pPr algn="l">
+              <a:lnSpc>
+                <a:spcPct val="115000"/>
+              </a:lnSpc>
+              <a:buNone/>
+            </a:pPr>
+            <a:endParaRPr lang="en-US" sz="1000" dirty="0"/>
+          </a:p>
+          <a:p>
+            <a:pPr algn="ctr">
+              <a:lnSpc>
+                <a:spcPct val="120000"/>
+              </a:lnSpc>
+              <a:buNone/>
+            </a:pPr>
+            <a:r>
+              <a:rPr lang="en-US" sz="2200" b="0" dirty="0">
+                <a:solidFill>
+                  <a:srgbClr val="FFFFFF"/>
+                </a:solidFill>
+                <a:latin typeface="Segoe UI Light"/>
+                <a:cs typeface="Segoe UI Light"/>
+              </a:rPr>
+              <a:t>We embedded our pages once, searched them per question, and pasted the winners into the prompt.</a:t>
+            </a:r>
+          </a:p>
+        </p:txBody>
+      </p:sp>
+    </p:spTree>
+    <p:extLst>
+      <p:ext uri="{BB962C8B-B14F-4D97-AF65-F5344CB8AC3E}">
+        <p14:creationId xmlns:p14="http://schemas.microsoft.com/office/powerpoint/2010/main" val="1958759625"/>
+      </p:ext>
+    </p:extLst>
+  </p:cSld>
+  <p:clrMapOvr>
+    <a:masterClrMapping/>
+  </p:clrMapOvr>
+</p:sld>
+</file>
+
+<file path=ppt/slides/slide34.xml><?xml version="1.0" encoding="utf-8"?>
+<p:sld xmlns:a="http://schemas.openxmlformats.org/drawingml/2006/main" xmlns:r="http://schemas.openxmlformats.org/officeDocument/2006/relationships" xmlns:p="http://schemas.openxmlformats.org/presentationml/2006/main">
+  <p:cSld>
+    <p:spTree>
+      <p:nvGrpSpPr>
+        <p:cNvPr id="1" name=""/>
+        <p:cNvGrpSpPr/>
+        <p:nvPr/>
+      </p:nvGrpSpPr>
+      <p:grpSpPr>
+        <a:xfrm>
+          <a:off x="0" y="0"/>
+          <a:ext cx="0" cy="0"/>
+          <a:chOff x="0" y="0"/>
+          <a:chExt cx="0" cy="0"/>
+        </a:xfrm>
+      </p:grpSpPr>
+      <p:sp>
+        <p:nvSpPr>
+          <p:cNvPr id="2" name="Title 1">
+            <a:extLst>
+              <a:ext uri="{FF2B5EF4-FFF2-40B4-BE49-F238E27FC236}">
                 <a16:creationId xmlns:a16="http://schemas.microsoft.com/office/drawing/2014/main" id="{D249E45E-D6A7-9780-F652-BAF86DFBCC00}"/>
               </a:ext>
             </a:extLst>
@@ -27011,7 +27634,7 @@
           <a:p>
             <a:fld id="{294A09A9-5501-47C1-A89A-A340965A2BE2}" type="slidenum">
               <a:rPr lang="en-US" smtClean="0"/>
-              <a:t>33</a:t>
+              <a:t>34</a:t>
             </a:fld>
             <a:endParaRPr lang="en-US" dirty="0"/>
           </a:p>
@@ -27334,7 +27957,7 @@
 </p:sld>
 </file>
 
-<file path=ppt/slides/slide34.xml><?xml version="1.0" encoding="utf-8"?>
+<file path=ppt/slides/slide35.xml><?xml version="1.0" encoding="utf-8"?>
 <p:sld xmlns:a="http://schemas.openxmlformats.org/drawingml/2006/main" xmlns:r="http://schemas.openxmlformats.org/officeDocument/2006/relationships" xmlns:p="http://schemas.openxmlformats.org/presentationml/2006/main">
   <p:cSld>
     <p:spTree>
@@ -33579,372 +34202,4 @@
     </a:ext>
   </a:extLst>
 </a:theme>
-</file>
-
-<file path=customXml/item1.xml><?xml version="1.0" encoding="utf-8"?>
-<p:properties xmlns:p="http://schemas.microsoft.com/office/2006/metadata/properties" xmlns:xsi="http://www.w3.org/2001/XMLSchema-instance" xmlns:pc="http://schemas.microsoft.com/office/infopath/2007/PartnerControls">
-  <documentManagement>
-    <_ip_UnifiedCompliancePolicyUIAction xmlns="http://schemas.microsoft.com/sharepoint/v3" xsi:nil="true"/>
-    <Image xmlns="71af3243-3dd4-4a8d-8c0d-dd76da1f02a5">
-      <Url xsi:nil="true"/>
-      <Description xsi:nil="true"/>
-    </Image>
-    <Status xmlns="71af3243-3dd4-4a8d-8c0d-dd76da1f02a5">Not started</Status>
-    <Background xmlns="71af3243-3dd4-4a8d-8c0d-dd76da1f02a5">false</Background>
-    <_ip_UnifiedCompliancePolicyProperties xmlns="http://schemas.microsoft.com/sharepoint/v3" xsi:nil="true"/>
-    <ImageTagsTaxHTField xmlns="71af3243-3dd4-4a8d-8c0d-dd76da1f02a5">
-      <Terms xmlns="http://schemas.microsoft.com/office/infopath/2007/PartnerControls"/>
-    </ImageTagsTaxHTField>
-    <TaxCatchAll xmlns="230e9df3-be65-4c73-a93b-d1236ebd677e" xsi:nil="true"/>
-    <MediaServiceKeyPoints xmlns="71af3243-3dd4-4a8d-8c0d-dd76da1f02a5" xsi:nil="true"/>
-  </documentManagement>
-</p:properties>
-</file>
-
-<file path=customXml/item2.xml><?xml version="1.0" encoding="utf-8"?>
-<ct:contentTypeSchema xmlns:ct="http://schemas.microsoft.com/office/2006/metadata/contentType" xmlns:ma="http://schemas.microsoft.com/office/2006/metadata/properties/metaAttributes" ct:_="" ma:_="" ma:contentTypeName="Document" ma:contentTypeID="0x01010079F111ED35F8CC479449609E8A0923A6" ma:contentTypeVersion="25" ma:contentTypeDescription="Create a new document." ma:contentTypeScope="" ma:versionID="e02306daf00165b375dc6a58966960be">
-  <xsd:schema xmlns:xsd="http://www.w3.org/2001/XMLSchema" xmlns:xs="http://www.w3.org/2001/XMLSchema" xmlns:p="http://schemas.microsoft.com/office/2006/metadata/properties" xmlns:ns1="http://schemas.microsoft.com/sharepoint/v3" xmlns:ns2="71af3243-3dd4-4a8d-8c0d-dd76da1f02a5" xmlns:ns3="16c05727-aa75-4e4a-9b5f-8a80a1165891" xmlns:ns4="230e9df3-be65-4c73-a93b-d1236ebd677e" targetNamespace="http://schemas.microsoft.com/office/2006/metadata/properties" ma:root="true" ma:fieldsID="df88fb76bf5f555224557953949c1ec9" ns1:_="" ns2:_="" ns3:_="" ns4:_="">
-    <xsd:import namespace="http://schemas.microsoft.com/sharepoint/v3"/>
-    <xsd:import namespace="71af3243-3dd4-4a8d-8c0d-dd76da1f02a5"/>
-    <xsd:import namespace="16c05727-aa75-4e4a-9b5f-8a80a1165891"/>
-    <xsd:import namespace="230e9df3-be65-4c73-a93b-d1236ebd677e"/>
-    <xsd:element name="properties">
-      <xsd:complexType>
-        <xsd:sequence>
-          <xsd:element name="documentManagement">
-            <xsd:complexType>
-              <xsd:all>
-                <xsd:element ref="ns2:Status" minOccurs="0"/>
-                <xsd:element ref="ns2:Image" minOccurs="0"/>
-                <xsd:element ref="ns2:MediaServiceMetadata" minOccurs="0"/>
-                <xsd:element ref="ns2:MediaServiceFastMetadata" minOccurs="0"/>
-                <xsd:element ref="ns2:MediaServiceOCR" minOccurs="0"/>
-                <xsd:element ref="ns2:MediaServiceAutoTags" minOccurs="0"/>
-                <xsd:element ref="ns2:MediaServiceEventHashCode" minOccurs="0"/>
-                <xsd:element ref="ns2:MediaServiceGenerationTime" minOccurs="0"/>
-                <xsd:element ref="ns3:SharedWithUsers" minOccurs="0"/>
-                <xsd:element ref="ns3:SharedWithDetails" minOccurs="0"/>
-                <xsd:element ref="ns2:MediaServiceAutoKeyPoints" minOccurs="0"/>
-                <xsd:element ref="ns2:MediaServiceKeyPoints" minOccurs="0"/>
-                <xsd:element ref="ns2:MediaServiceDateTaken" minOccurs="0"/>
-                <xsd:element ref="ns1:_ip_UnifiedCompliancePolicyProperties" minOccurs="0"/>
-                <xsd:element ref="ns1:_ip_UnifiedCompliancePolicyUIAction" minOccurs="0"/>
-                <xsd:element ref="ns4:TaxCatchAll" minOccurs="0"/>
-                <xsd:element ref="ns2:ImageTagsTaxHTField" minOccurs="0"/>
-                <xsd:element ref="ns2:MediaServiceLocation" minOccurs="0"/>
-                <xsd:element ref="ns2:MediaLengthInSeconds" minOccurs="0"/>
-                <xsd:element ref="ns2:Background" minOccurs="0"/>
-                <xsd:element ref="ns2:MediaServiceSearchProperties" minOccurs="0"/>
-              </xsd:all>
-            </xsd:complexType>
-          </xsd:element>
-        </xsd:sequence>
-      </xsd:complexType>
-    </xsd:element>
-  </xsd:schema>
-  <xsd:schema xmlns:xsd="http://www.w3.org/2001/XMLSchema" xmlns:xs="http://www.w3.org/2001/XMLSchema" xmlns:dms="http://schemas.microsoft.com/office/2006/documentManagement/types" xmlns:pc="http://schemas.microsoft.com/office/infopath/2007/PartnerControls" targetNamespace="http://schemas.microsoft.com/sharepoint/v3" elementFormDefault="qualified">
-    <xsd:import namespace="http://schemas.microsoft.com/office/2006/documentManagement/types"/>
-    <xsd:import namespace="http://schemas.microsoft.com/office/infopath/2007/PartnerControls"/>
-    <xsd:element name="_ip_UnifiedCompliancePolicyProperties" ma:index="20" nillable="true" ma:displayName="Unified Compliance Policy Properties" ma:hidden="true" ma:internalName="_ip_UnifiedCompliancePolicyProperties" ma:readOnly="false">
-      <xsd:simpleType>
-        <xsd:restriction base="dms:Note"/>
-      </xsd:simpleType>
-    </xsd:element>
-    <xsd:element name="_ip_UnifiedCompliancePolicyUIAction" ma:index="21" nillable="true" ma:displayName="Unified Compliance Policy UI Action" ma:hidden="true" ma:internalName="_ip_UnifiedCompliancePolicyUIAction" ma:readOnly="false">
-      <xsd:simpleType>
-        <xsd:restriction base="dms:Text"/>
-      </xsd:simpleType>
-    </xsd:element>
-  </xsd:schema>
-  <xsd:schema xmlns:xsd="http://www.w3.org/2001/XMLSchema" xmlns:xs="http://www.w3.org/2001/XMLSchema" xmlns:dms="http://schemas.microsoft.com/office/2006/documentManagement/types" xmlns:pc="http://schemas.microsoft.com/office/infopath/2007/PartnerControls" targetNamespace="71af3243-3dd4-4a8d-8c0d-dd76da1f02a5" elementFormDefault="qualified">
-    <xsd:import namespace="http://schemas.microsoft.com/office/2006/documentManagement/types"/>
-    <xsd:import namespace="http://schemas.microsoft.com/office/infopath/2007/PartnerControls"/>
-    <xsd:element name="Status" ma:index="2" nillable="true" ma:displayName="Status" ma:default="Not started" ma:format="Dropdown" ma:internalName="Status" ma:readOnly="false">
-      <xsd:simpleType>
-        <xsd:restriction base="dms:Choice">
-          <xsd:enumeration value="Not started"/>
-          <xsd:enumeration value="In Progress"/>
-          <xsd:enumeration value="Completed"/>
-        </xsd:restriction>
-      </xsd:simpleType>
-    </xsd:element>
-    <xsd:element name="Image" ma:index="3" nillable="true" ma:displayName="Image" ma:format="Image" ma:internalName="Image" ma:readOnly="false">
-      <xsd:complexType>
-        <xsd:complexContent>
-          <xsd:extension base="dms:URL">
-            <xsd:sequence>
-              <xsd:element name="Url" type="dms:ValidUrl" minOccurs="0" nillable="true"/>
-              <xsd:element name="Description" type="xsd:string" nillable="true"/>
-            </xsd:sequence>
-          </xsd:extension>
-        </xsd:complexContent>
-      </xsd:complexType>
-    </xsd:element>
-    <xsd:element name="MediaServiceMetadata" ma:index="8" nillable="true" ma:displayName="MediaServiceMetadata" ma:hidden="true" ma:internalName="MediaServiceMetadata" ma:readOnly="true">
-      <xsd:simpleType>
-        <xsd:restriction base="dms:Note"/>
-      </xsd:simpleType>
-    </xsd:element>
-    <xsd:element name="MediaServiceFastMetadata" ma:index="9" nillable="true" ma:displayName="MediaServiceFastMetadata" ma:hidden="true" ma:internalName="MediaServiceFastMetadata" ma:readOnly="true">
-      <xsd:simpleType>
-        <xsd:restriction base="dms:Note"/>
-      </xsd:simpleType>
-    </xsd:element>
-    <xsd:element name="MediaServiceOCR" ma:index="10" nillable="true" ma:displayName="MediaServiceOCR" ma:hidden="true" ma:internalName="MediaServiceOCR" ma:readOnly="true">
-      <xsd:simpleType>
-        <xsd:restriction base="dms:Note"/>
-      </xsd:simpleType>
-    </xsd:element>
-    <xsd:element name="MediaServiceAutoTags" ma:index="11" nillable="true" ma:displayName="MediaServiceAutoTags" ma:hidden="true" ma:internalName="MediaServiceAutoTags" ma:readOnly="true">
-      <xsd:simpleType>
-        <xsd:restriction base="dms:Text"/>
-      </xsd:simpleType>
-    </xsd:element>
-    <xsd:element name="MediaServiceEventHashCode" ma:index="12" nillable="true" ma:displayName="MediaServiceEventHashCode" ma:hidden="true" ma:internalName="MediaServiceEventHashCode" ma:readOnly="true">
-      <xsd:simpleType>
-        <xsd:restriction base="dms:Text"/>
-      </xsd:simpleType>
-    </xsd:element>
-    <xsd:element name="MediaServiceGenerationTime" ma:index="13" nillable="true" ma:displayName="MediaServiceGenerationTime" ma:hidden="true" ma:internalName="MediaServiceGenerationTime" ma:readOnly="true">
-      <xsd:simpleType>
-        <xsd:restriction base="dms:Text"/>
-      </xsd:simpleType>
-    </xsd:element>
-    <xsd:element name="MediaServiceAutoKeyPoints" ma:index="16" nillable="true" ma:displayName="MediaServiceAutoKeyPoints" ma:hidden="true" ma:internalName="MediaServiceAutoKeyPoints" ma:readOnly="true">
-      <xsd:simpleType>
-        <xsd:restriction base="dms:Note"/>
-      </xsd:simpleType>
-    </xsd:element>
-    <xsd:element name="MediaServiceKeyPoints" ma:index="17" nillable="true" ma:displayName="KeyPoints" ma:hidden="true" ma:internalName="MediaServiceKeyPoints" ma:readOnly="false">
-      <xsd:simpleType>
-        <xsd:restriction base="dms:Note"/>
-      </xsd:simpleType>
-    </xsd:element>
-    <xsd:element name="MediaServiceDateTaken" ma:index="18" nillable="true" ma:displayName="MediaServiceDateTaken" ma:hidden="true" ma:internalName="MediaServiceDateTaken" ma:readOnly="true">
-      <xsd:simpleType>
-        <xsd:restriction base="dms:Text"/>
-      </xsd:simpleType>
-    </xsd:element>
-    <xsd:element name="ImageTagsTaxHTField" ma:index="25" nillable="true" ma:taxonomy="true" ma:internalName="ImageTagsTaxHTField" ma:taxonomyFieldName="MediaServiceImageTags" ma:displayName="Image Tags" ma:readOnly="false" ma:fieldId="{5cf76f15-5ced-4ddc-b409-7134ff3c332f}" ma:taxonomyMulti="true" ma:sspId="e385fb40-52d4-4fae-9c5b-3e8ff8a5878e" ma:termSetId="09814cd3-568e-fe90-9814-8d621ff8fb84" ma:anchorId="fba54fb3-c3e1-fe81-a776-ca4b69148c4d" ma:open="true" ma:isKeyword="false">
-      <xsd:complexType>
-        <xsd:sequence>
-          <xsd:element ref="pc:Terms" minOccurs="0" maxOccurs="1"/>
-        </xsd:sequence>
-      </xsd:complexType>
-    </xsd:element>
-    <xsd:element name="MediaServiceLocation" ma:index="26" nillable="true" ma:displayName="Location" ma:hidden="true" ma:internalName="MediaServiceLocation" ma:readOnly="true">
-      <xsd:simpleType>
-        <xsd:restriction base="dms:Text"/>
-      </xsd:simpleType>
-    </xsd:element>
-    <xsd:element name="MediaLengthInSeconds" ma:index="27" nillable="true" ma:displayName="MediaLengthInSeconds" ma:hidden="true" ma:internalName="MediaLengthInSeconds" ma:readOnly="true">
-      <xsd:simpleType>
-        <xsd:restriction base="dms:Unknown"/>
-      </xsd:simpleType>
-    </xsd:element>
-    <xsd:element name="Background" ma:index="28" nillable="true" ma:displayName="Background" ma:default="0" ma:format="Dropdown" ma:internalName="Background">
-      <xsd:simpleType>
-        <xsd:restriction base="dms:Boolean"/>
-      </xsd:simpleType>
-    </xsd:element>
-    <xsd:element name="MediaServiceSearchProperties" ma:index="29" nillable="true" ma:displayName="MediaServiceSearchProperties" ma:hidden="true" ma:internalName="MediaServiceSearchProperties" ma:readOnly="true">
-      <xsd:simpleType>
-        <xsd:restriction base="dms:Note"/>
-      </xsd:simpleType>
-    </xsd:element>
-  </xsd:schema>
-  <xsd:schema xmlns:xsd="http://www.w3.org/2001/XMLSchema" xmlns:xs="http://www.w3.org/2001/XMLSchema" xmlns:dms="http://schemas.microsoft.com/office/2006/documentManagement/types" xmlns:pc="http://schemas.microsoft.com/office/infopath/2007/PartnerControls" targetNamespace="16c05727-aa75-4e4a-9b5f-8a80a1165891" elementFormDefault="qualified">
-    <xsd:import namespace="http://schemas.microsoft.com/office/2006/documentManagement/types"/>
-    <xsd:import namespace="http://schemas.microsoft.com/office/infopath/2007/PartnerControls"/>
-    <xsd:element name="SharedWithUsers" ma:index="14" nillable="true" ma:displayName="Shared With" ma:hidden="true" ma:internalName="SharedWithUsers" ma:readOnly="true">
-      <xsd:complexType>
-        <xsd:complexContent>
-          <xsd:extension base="dms:UserMulti">
-            <xsd:sequence>
-              <xsd:element name="UserInfo" minOccurs="0" maxOccurs="unbounded">
-                <xsd:complexType>
-                  <xsd:sequence>
-                    <xsd:element name="DisplayName" type="xsd:string" minOccurs="0"/>
-                    <xsd:element name="AccountId" type="dms:UserId" minOccurs="0" nillable="true"/>
-                    <xsd:element name="AccountType" type="xsd:string" minOccurs="0"/>
-                  </xsd:sequence>
-                </xsd:complexType>
-              </xsd:element>
-            </xsd:sequence>
-          </xsd:extension>
-        </xsd:complexContent>
-      </xsd:complexType>
-    </xsd:element>
-    <xsd:element name="SharedWithDetails" ma:index="15" nillable="true" ma:displayName="Shared With Details" ma:hidden="true" ma:internalName="SharedWithDetails" ma:readOnly="true">
-      <xsd:simpleType>
-        <xsd:restriction base="dms:Note"/>
-      </xsd:simpleType>
-    </xsd:element>
-  </xsd:schema>
-  <xsd:schema xmlns:xsd="http://www.w3.org/2001/XMLSchema" xmlns:xs="http://www.w3.org/2001/XMLSchema" xmlns:dms="http://schemas.microsoft.com/office/2006/documentManagement/types" xmlns:pc="http://schemas.microsoft.com/office/infopath/2007/PartnerControls" targetNamespace="230e9df3-be65-4c73-a93b-d1236ebd677e" elementFormDefault="qualified">
-    <xsd:import namespace="http://schemas.microsoft.com/office/2006/documentManagement/types"/>
-    <xsd:import namespace="http://schemas.microsoft.com/office/infopath/2007/PartnerControls"/>
-    <xsd:element name="TaxCatchAll" ma:index="23" nillable="true" ma:displayName="Taxonomy Catch All Column" ma:hidden="true" ma:list="{3f6bfcbc-3db3-4ae6-bd76-326f0798ad28}" ma:internalName="TaxCatchAll" ma:readOnly="false" ma:showField="CatchAllData" ma:web="16c05727-aa75-4e4a-9b5f-8a80a1165891">
-      <xsd:complexType>
-        <xsd:complexContent>
-          <xsd:extension base="dms:MultiChoiceLookup">
-            <xsd:sequence>
-              <xsd:element name="Value" type="dms:Lookup" maxOccurs="unbounded" minOccurs="0" nillable="true"/>
-            </xsd:sequence>
-          </xsd:extension>
-        </xsd:complexContent>
-      </xsd:complexType>
-    </xsd:element>
-  </xsd:schema>
-  <xsd:schema xmlns="http://schemas.openxmlformats.org/package/2006/metadata/core-properties" xmlns:xsd="http://www.w3.org/2001/XMLSchema" xmlns:xsi="http://www.w3.org/2001/XMLSchema-instance" xmlns:dc="http://purl.org/dc/elements/1.1/" xmlns:dcterms="http://purl.org/dc/terms/" xmlns:odoc="http://schemas.microsoft.com/internal/obd" targetNamespace="http://schemas.openxmlformats.org/package/2006/metadata/core-properties" elementFormDefault="qualified" attributeFormDefault="unqualified" blockDefault="#all">
-    <xsd:import namespace="http://purl.org/dc/elements/1.1/" schemaLocation="http://dublincore.org/schemas/xmls/qdc/2003/04/02/dc.xsd"/>
-    <xsd:import namespace="http://purl.org/dc/terms/" schemaLocation="http://dublincore.org/schemas/xmls/qdc/2003/04/02/dcterms.xsd"/>
-    <xsd:element name="coreProperties" type="CT_coreProperties"/>
-    <xsd:complexType name="CT_coreProperties">
-      <xsd:all>
-        <xsd:element ref="dc:creator" minOccurs="0" maxOccurs="1"/>
-        <xsd:element ref="dcterms:created" minOccurs="0" maxOccurs="1"/>
-        <xsd:element ref="dc:identifier" minOccurs="0" maxOccurs="1"/>
-        <xsd:element name="contentType" minOccurs="0" maxOccurs="1" type="xsd:string" ma:displayName="Content Type"/>
-        <xsd:element ref="dc:title" minOccurs="0" maxOccurs="1" ma:index="1" ma:displayName="Title"/>
-        <xsd:element ref="dc:subject" minOccurs="0" maxOccurs="1"/>
-        <xsd:element ref="dc:description" minOccurs="0" maxOccurs="1"/>
-        <xsd:element name="keywords" minOccurs="0" maxOccurs="1" type="xsd:string"/>
-        <xsd:element ref="dc:language" minOccurs="0" maxOccurs="1"/>
-        <xsd:element name="category" minOccurs="0" maxOccurs="1" type="xsd:string"/>
-        <xsd:element name="version" minOccurs="0" maxOccurs="1" type="xsd:string"/>
-        <xsd:element name="revision" minOccurs="0" maxOccurs="1" type="xsd:string">
-          <xsd:annotation>
-            <xsd:documentation>
-                        This value indicates the number of saves or revisions. The application is responsible for updating this value after each revision.
-                    </xsd:documentation>
-          </xsd:annotation>
-        </xsd:element>
-        <xsd:element name="lastModifiedBy" minOccurs="0" maxOccurs="1" type="xsd:string"/>
-        <xsd:element ref="dcterms:modified" minOccurs="0" maxOccurs="1"/>
-        <xsd:element name="contentStatus" minOccurs="0" maxOccurs="1" type="xsd:string"/>
-      </xsd:all>
-    </xsd:complexType>
-  </xsd:schema>
-  <xs:schema xmlns:pc="http://schemas.microsoft.com/office/infopath/2007/PartnerControls" xmlns:xs="http://www.w3.org/2001/XMLSchema" targetNamespace="http://schemas.microsoft.com/office/infopath/2007/PartnerControls" elementFormDefault="qualified" attributeFormDefault="unqualified">
-    <xs:element name="Person">
-      <xs:complexType>
-        <xs:sequence>
-          <xs:element ref="pc:DisplayName" minOccurs="0"/>
-          <xs:element ref="pc:AccountId" minOccurs="0"/>
-          <xs:element ref="pc:AccountType" minOccurs="0"/>
-        </xs:sequence>
-      </xs:complexType>
-    </xs:element>
-    <xs:element name="DisplayName" type="xs:string"/>
-    <xs:element name="AccountId" type="xs:string"/>
-    <xs:element name="AccountType" type="xs:string"/>
-    <xs:element name="BDCAssociatedEntity">
-      <xs:complexType>
-        <xs:sequence>
-          <xs:element ref="pc:BDCEntity" minOccurs="0" maxOccurs="unbounded"/>
-        </xs:sequence>
-        <xs:attribute ref="pc:EntityNamespace"/>
-        <xs:attribute ref="pc:EntityName"/>
-        <xs:attribute ref="pc:SystemInstanceName"/>
-        <xs:attribute ref="pc:AssociationName"/>
-      </xs:complexType>
-    </xs:element>
-    <xs:attribute name="EntityNamespace" type="xs:string"/>
-    <xs:attribute name="EntityName" type="xs:string"/>
-    <xs:attribute name="SystemInstanceName" type="xs:string"/>
-    <xs:attribute name="AssociationName" type="xs:string"/>
-    <xs:element name="BDCEntity">
-      <xs:complexType>
-        <xs:sequence>
-          <xs:element ref="pc:EntityDisplayName" minOccurs="0"/>
-          <xs:element ref="pc:EntityInstanceReference" minOccurs="0"/>
-          <xs:element ref="pc:EntityId1" minOccurs="0"/>
-          <xs:element ref="pc:EntityId2" minOccurs="0"/>
-          <xs:element ref="pc:EntityId3" minOccurs="0"/>
-          <xs:element ref="pc:EntityId4" minOccurs="0"/>
-          <xs:element ref="pc:EntityId5" minOccurs="0"/>
-        </xs:sequence>
-      </xs:complexType>
-    </xs:element>
-    <xs:element name="EntityDisplayName" type="xs:string"/>
-    <xs:element name="EntityInstanceReference" type="xs:string"/>
-    <xs:element name="EntityId1" type="xs:string"/>
-    <xs:element name="EntityId2" type="xs:string"/>
-    <xs:element name="EntityId3" type="xs:string"/>
-    <xs:element name="EntityId4" type="xs:string"/>
-    <xs:element name="EntityId5" type="xs:string"/>
-    <xs:element name="Terms">
-      <xs:complexType>
-        <xs:sequence>
-          <xs:element ref="pc:TermInfo" minOccurs="0" maxOccurs="unbounded"/>
-        </xs:sequence>
-      </xs:complexType>
-    </xs:element>
-    <xs:element name="TermInfo">
-      <xs:complexType>
-        <xs:sequence>
-          <xs:element ref="pc:TermName" minOccurs="0"/>
-          <xs:element ref="pc:TermId" minOccurs="0"/>
-        </xs:sequence>
-      </xs:complexType>
-    </xs:element>
-    <xs:element name="TermName" type="xs:string"/>
-    <xs:element name="TermId" type="xs:string"/>
-  </xs:schema>
-</ct:contentTypeSchema>
-</file>
-
-<file path=customXml/item3.xml><?xml version="1.0" encoding="utf-8"?>
-<?mso-contentType ?>
-<FormTemplates xmlns="http://schemas.microsoft.com/sharepoint/v3/contenttype/forms">
-  <Display>DocumentLibraryForm</Display>
-  <Edit>DocumentLibraryForm</Edit>
-  <New>DocumentLibraryForm</New>
-</FormTemplates>
-</file>
-
-<file path=customXml/itemProps1.xml><?xml version="1.0" encoding="utf-8"?>
-<ds:datastoreItem xmlns:ds="http://schemas.openxmlformats.org/officeDocument/2006/customXml" ds:itemID="{EA4A3FD6-E6BF-490E-B6B4-6A011394B0EB}">
-  <ds:schemaRefs>
-    <ds:schemaRef ds:uri="http://schemas.microsoft.com/office/2006/metadata/properties"/>
-    <ds:schemaRef ds:uri="http://schemas.microsoft.com/office/infopath/2007/PartnerControls"/>
-    <ds:schemaRef ds:uri="http://schemas.microsoft.com/sharepoint/v3"/>
-    <ds:schemaRef ds:uri="71af3243-3dd4-4a8d-8c0d-dd76da1f02a5"/>
-    <ds:schemaRef ds:uri="230e9df3-be65-4c73-a93b-d1236ebd677e"/>
-  </ds:schemaRefs>
-</ds:datastoreItem>
-</file>
-
-<file path=customXml/itemProps2.xml><?xml version="1.0" encoding="utf-8"?>
-<ds:datastoreItem xmlns:ds="http://schemas.openxmlformats.org/officeDocument/2006/customXml" ds:itemID="{62CF8670-35D1-4455-AC7A-762B7388BE22}">
-  <ds:schemaRefs>
-    <ds:schemaRef ds:uri="http://schemas.microsoft.com/office/2006/metadata/contentType"/>
-    <ds:schemaRef ds:uri="http://schemas.microsoft.com/office/2006/metadata/properties/metaAttributes"/>
-    <ds:schemaRef ds:uri="http://www.w3.org/2001/XMLSchema"/>
-    <ds:schemaRef ds:uri="http://schemas.microsoft.com/office/2006/metadata/properties"/>
-    <ds:schemaRef ds:uri="http://schemas.microsoft.com/sharepoint/v3"/>
-    <ds:schemaRef ds:uri="71af3243-3dd4-4a8d-8c0d-dd76da1f02a5"/>
-    <ds:schemaRef ds:uri="16c05727-aa75-4e4a-9b5f-8a80a1165891"/>
-    <ds:schemaRef ds:uri="230e9df3-be65-4c73-a93b-d1236ebd677e"/>
-    <ds:schemaRef ds:uri="http://schemas.microsoft.com/office/2006/documentManagement/types"/>
-    <ds:schemaRef ds:uri="http://schemas.microsoft.com/office/infopath/2007/PartnerControls"/>
-    <ds:schemaRef ds:uri="http://schemas.openxmlformats.org/package/2006/metadata/core-properties"/>
-    <ds:schemaRef ds:uri="http://purl.org/dc/elements/1.1/"/>
-    <ds:schemaRef ds:uri="http://purl.org/dc/terms/"/>
-    <ds:schemaRef ds:uri="http://schemas.microsoft.com/internal/obd"/>
-  </ds:schemaRefs>
-</ds:datastoreItem>
-</file>
-
-<file path=customXml/itemProps3.xml><?xml version="1.0" encoding="utf-8"?>
-<ds:datastoreItem xmlns:ds="http://schemas.openxmlformats.org/officeDocument/2006/customXml" ds:itemID="{43C4A95C-9007-4EA6-944B-306B6F2A0100}">
-  <ds:schemaRefs>
-    <ds:schemaRef ds:uri="http://schemas.microsoft.com/sharepoint/v3/contenttype/forms"/>
-  </ds:schemaRefs>
-</ds:datastoreItem>
-</file>
-
-<file path=docMetadata/LabelInfo.xml><?xml version="1.0" encoding="utf-8"?>
-<clbl:labelList xmlns:clbl="http://schemas.microsoft.com/office/2020/mipLabelMetadata"/>
 </file>
</xml_diff>